<commit_message>
Add management PPT guide: uses, report explanation, and config
Expand generate_coverage_validator_ppt.py to 17 slides covering business need,
8-card report sections, test plan validation, and full teammate configuration.

Co-authored-by: Cursor <cursoragent@cursor.com>
</commit_message>
<xml_diff>
--- a/docs/MSC-Code-Coverage-Validator-Guide.pptx
+++ b/docs/MSC-Code-Coverage-Validator-Guide.pptx
@@ -17,6 +17,10 @@
     <p:sldId id="265" r:id="rId16"/>
     <p:sldId id="266" r:id="rId17"/>
     <p:sldId id="267" r:id="rId18"/>
+    <p:sldId id="268" r:id="rId19"/>
+    <p:sldId id="269" r:id="rId20"/>
+    <p:sldId id="270" r:id="rId21"/>
+    <p:sldId id="271" r:id="rId22"/>
   </p:sldIdLst>
   <p:sldSz cx="9144000" cy="6858000" type="screen4x3"/>
   <p:notesSz cx="6858000" cy="9144000"/>
@@ -3115,7 +3119,7 @@
         </p:nvSpPr>
         <p:spPr>
           <a:xfrm>
-            <a:off x="640080" y="1828800"/>
+            <a:off x="640080" y="1645920"/>
             <a:ext cx="7863840" cy="1097280"/>
           </a:xfrm>
           <a:prstGeom prst="rect">
@@ -3130,7 +3134,7 @@
           <a:lstStyle/>
           <a:p>
             <a:pPr>
-              <a:defRPr sz="3800" b="1">
+              <a:defRPr sz="3600" b="1">
                 <a:solidFill>
                   <a:srgbClr val="FFFFFF"/>
                 </a:solidFill>
@@ -3150,8 +3154,8 @@
         </p:nvSpPr>
         <p:spPr>
           <a:xfrm>
-            <a:off x="640080" y="2926080"/>
-            <a:ext cx="7863840" cy="1097280"/>
+            <a:off x="640080" y="2743200"/>
+            <a:ext cx="7863840" cy="1280160"/>
           </a:xfrm>
           <a:prstGeom prst="rect">
             <a:avLst/>
@@ -3165,19 +3169,19 @@
           <a:lstStyle/>
           <a:p>
             <a:pPr>
-              <a:defRPr sz="1800">
+              <a:defRPr sz="2000">
                 <a:solidFill>
                   <a:srgbClr val="BFDBFE"/>
                 </a:solidFill>
               </a:defRPr>
             </a:pPr>
             <a:r>
-              <a:t>Jira acceptance criteria ↔ GitHub implementation</a:t>
-            </a:r>
-          </a:p>
-          <a:p>
-            <a:r>
-              <a:t>Management-ready coverage report for MSC stories</a:t>
+              <a:t>Management guide</a:t>
+            </a:r>
+          </a:p>
+          <a:p>
+            <a:r>
+              <a:t>Business need · Uses · HTML report · Configuration</a:t>
             </a:r>
           </a:p>
         </p:txBody>
@@ -3190,8 +3194,8 @@
         </p:nvSpPr>
         <p:spPr>
           <a:xfrm>
-            <a:off x="640080" y="5394960"/>
-            <a:ext cx="7863840" cy="365760"/>
+            <a:off x="640080" y="5303520"/>
+            <a:ext cx="7863840" cy="457200"/>
           </a:xfrm>
           <a:prstGeom prst="rect">
             <a:avLst/>
@@ -3212,7 +3216,12 @@
               </a:defRPr>
             </a:pPr>
             <a:r>
-              <a:t>Pegasus QA Agents Lab · Media Supply Chain · wbdstreaming.atlassian.net</a:t>
+              <a:t>Pegasus QA Agents Lab · MSC · wbdstreaming.atlassian.net</a:t>
+            </a:r>
+          </a:p>
+          <a:p>
+            <a:r>
+              <a:t>github.com/mgunjal11/pegasus-qa-agents-lab</a:t>
             </a:r>
           </a:p>
         </p:txBody>
@@ -3258,7 +3267,7 @@
             <a:avLst/>
           </a:prstGeom>
           <a:solidFill>
-            <a:srgbClr val="15803D"/>
+            <a:srgbClr val="5B21B6"/>
           </a:solidFill>
           <a:ln>
             <a:noFill/>
@@ -3333,7 +3342,7 @@
               </a:defRPr>
             </a:pPr>
             <a:r>
-              <a:t>5–7</a:t>
+              <a:t>4–5</a:t>
             </a:r>
           </a:p>
         </p:txBody>
@@ -3361,14 +3370,14 @@
           <a:lstStyle/>
           <a:p>
             <a:pPr>
-              <a:defRPr sz="2600" b="1">
+              <a:defRPr sz="2400" b="1">
                 <a:solidFill>
                   <a:srgbClr val="FFFFFF"/>
                 </a:solidFill>
               </a:defRPr>
             </a:pPr>
             <a:r>
-              <a:t>§5–§7 Review &amp; actions</a:t>
+              <a:t>§4–§5 Ownership &amp; traceability</a:t>
             </a:r>
           </a:p>
         </p:txBody>
@@ -3381,8 +3390,8 @@
         </p:nvSpPr>
         <p:spPr>
           <a:xfrm>
-            <a:off x="502920" y="1051560"/>
-            <a:ext cx="8046720" cy="365760"/>
+            <a:off x="502920" y="1234440"/>
+            <a:ext cx="8046720" cy="5120640"/>
           </a:xfrm>
           <a:prstGeom prst="rect">
             <a:avLst/>
@@ -3390,41 +3399,6 @@
           <a:noFill/>
         </p:spPr>
         <p:txBody>
-          <a:bodyPr wrap="none">
-            <a:spAutoFit/>
-          </a:bodyPr>
-          <a:lstStyle/>
-          <a:p>
-            <a:pPr>
-              <a:defRPr sz="1300" i="1">
-                <a:solidFill>
-                  <a:srgbClr val="64748B"/>
-                </a:solidFill>
-              </a:defRPr>
-            </a:pPr>
-            <a:r>
-              <a:t>Findings and next steps</a:t>
-            </a:r>
-          </a:p>
-        </p:txBody>
-      </p:sp>
-      <p:sp>
-        <p:nvSpPr>
-          <p:cNvPr id="6" name="TextBox 5"/>
-          <p:cNvSpPr txBox="1"/>
-          <p:nvPr/>
-        </p:nvSpPr>
-        <p:spPr>
-          <a:xfrm>
-            <a:off x="502920" y="1417320"/>
-            <a:ext cx="8046720" cy="5120640"/>
-          </a:xfrm>
-          <a:prstGeom prst="rect">
-            <a:avLst/>
-          </a:prstGeom>
-          <a:noFill/>
-        </p:spPr>
-        <p:txBody>
           <a:bodyPr wrap="square">
             <a:spAutoFit/>
           </a:bodyPr>
@@ -3432,76 +3406,91 @@
           <a:p>
             <a:pPr>
               <a:spcAft>
-                <a:spcPts val="800"/>
-              </a:spcAft>
-              <a:defRPr sz="1700">
+                <a:spcPts val="600"/>
+              </a:spcAft>
+              <a:defRPr sz="1600">
                 <a:solidFill>
                   <a:srgbClr val="0F172A"/>
                 </a:solidFill>
               </a:defRPr>
             </a:pPr>
             <a:r>
-              <a:t>§5 Implementation review</a:t>
+              <a:t>§4 Dev vs QA ownership</a:t>
             </a:r>
           </a:p>
           <a:p>
             <a:pPr lvl="1">
               <a:spcAft>
-                <a:spcPts val="800"/>
-              </a:spcAft>
-              <a:defRPr sz="1500">
+                <a:spcPts val="600"/>
+              </a:spcAft>
+              <a:defRPr sz="1400">
                 <a:solidFill>
                   <a:srgbClr val="334155"/>
                 </a:solidFill>
               </a:defRPr>
             </a:pPr>
             <a:r>
-              <a:t>  • Correctly implemented — strengths backed by code evidence</a:t>
+              <a:t>  • Left: Covered by dev tests (file + test name evidence)</a:t>
             </a:r>
           </a:p>
           <a:p>
             <a:pPr lvl="1">
               <a:spcAft>
-                <a:spcPts val="800"/>
-              </a:spcAft>
-              <a:defRPr sz="1500">
+                <a:spcPts val="600"/>
+              </a:spcAft>
+              <a:defRPr sz="1400">
                 <a:solidFill>
                   <a:srgbClr val="334155"/>
                 </a:solidFill>
               </a:defRPr>
             </a:pPr>
             <a:r>
-              <a:t>  • Gaps and concerns — severity: High · Medium · Critical</a:t>
-            </a:r>
-          </a:p>
-          <a:p>
-            <a:pPr>
-              <a:spcAft>
-                <a:spcPts val="800"/>
-              </a:spcAft>
-              <a:defRPr sz="1700">
+              <a:t>  • Right: QA handoff (E2E Monitor, manual SIT, regression for related bugs)</a:t>
+            </a:r>
+          </a:p>
+          <a:p>
+            <a:pPr>
+              <a:spcAft>
+                <a:spcPts val="600"/>
+              </a:spcAft>
+              <a:defRPr sz="1600">
                 <a:solidFill>
                   <a:srgbClr val="0F172A"/>
                 </a:solidFill>
               </a:defRPr>
             </a:pPr>
             <a:r>
-              <a:t>§6 Assumptions and open questions — Inferred context needing confirmation</a:t>
-            </a:r>
-          </a:p>
-          <a:p>
-            <a:pPr>
-              <a:spcAft>
-                <a:spcPts val="800"/>
-              </a:spcAft>
-              <a:defRPr sz="1700">
-                <a:solidFill>
-                  <a:srgbClr val="0F172A"/>
-                </a:solidFill>
-              </a:defRPr>
-            </a:pPr>
-            <a:r>
-              <a:t>§7 Recommended actions — Numbered dev and QA to-do list before release</a:t>
+              <a:t>§5 Requirements traceability (core audit table)</a:t>
+            </a:r>
+          </a:p>
+          <a:p>
+            <a:pPr lvl="1">
+              <a:spcAft>
+                <a:spcPts val="600"/>
+              </a:spcAft>
+              <a:defRPr sz="1400">
+                <a:solidFill>
+                  <a:srgbClr val="334155"/>
+                </a:solidFill>
+              </a:defRPr>
+            </a:pPr>
+            <a:r>
+              <a:t>  • Per row: Code status · Dev test status · Owner · QA scope · Evidence paths</a:t>
+            </a:r>
+          </a:p>
+          <a:p>
+            <a:pPr lvl="1">
+              <a:spcAft>
+                <a:spcPts val="600"/>
+              </a:spcAft>
+              <a:defRPr sz="1400">
+                <a:solidFill>
+                  <a:srgbClr val="334155"/>
+                </a:solidFill>
+              </a:defRPr>
+            </a:pPr>
+            <a:r>
+              <a:t>  • Badges: Implemented/Covered/Partial/Missing, Dev/Shared/QA, Unit/Integration/E2E</a:t>
             </a:r>
           </a:p>
         </p:txBody>
@@ -3547,7 +3536,7 @@
             <a:avLst/>
           </a:prstGeom>
           <a:solidFill>
-            <a:srgbClr val="1E40AF"/>
+            <a:srgbClr val="15803D"/>
           </a:solidFill>
           <a:ln>
             <a:noFill/>
@@ -3577,13 +3566,65 @@
       </p:sp>
       <p:sp>
         <p:nvSpPr>
-          <p:cNvPr id="3" name="TextBox 2"/>
+          <p:cNvPr id="3" name="Oval 2"/>
+          <p:cNvSpPr/>
+          <p:nvPr/>
+        </p:nvSpPr>
+        <p:spPr>
+          <a:xfrm>
+            <a:off x="320040" y="201168"/>
+            <a:ext cx="502920" cy="502920"/>
+          </a:xfrm>
+          <a:prstGeom prst="ellipse">
+            <a:avLst/>
+          </a:prstGeom>
+          <a:solidFill>
+            <a:srgbClr val="FFFFFF"/>
+          </a:solidFill>
+          <a:ln>
+            <a:noFill/>
+          </a:ln>
+        </p:spPr>
+        <p:style>
+          <a:lnRef idx="1">
+            <a:schemeClr val="accent1"/>
+          </a:lnRef>
+          <a:fillRef idx="3">
+            <a:schemeClr val="accent1"/>
+          </a:fillRef>
+          <a:effectRef idx="2">
+            <a:schemeClr val="accent1"/>
+          </a:effectRef>
+          <a:fontRef idx="minor">
+            <a:schemeClr val="lt1"/>
+          </a:fontRef>
+        </p:style>
+        <p:txBody>
+          <a:bodyPr rtlCol="0" anchor="ctr"/>
+          <a:lstStyle/>
+          <a:p>
+            <a:pPr algn="ctr">
+              <a:defRPr sz="1400" b="1">
+                <a:solidFill>
+                  <a:srgbClr val="FFFFFF"/>
+                </a:solidFill>
+              </a:defRPr>
+            </a:pPr>
+            <a:r>
+              <a:t>6–8</a:t>
+            </a:r>
+          </a:p>
+        </p:txBody>
+      </p:sp>
+      <p:sp>
+        <p:nvSpPr>
+          <p:cNvPr id="4" name="TextBox 3"/>
           <p:cNvSpPr txBox="1"/>
           <p:nvPr/>
         </p:nvSpPr>
         <p:spPr>
           <a:xfrm>
-            <a:off x="411480" y="164592"/>
+            <a:off x="960120" y="164592"/>
             <a:ext cx="7772400" cy="640080"/>
           </a:xfrm>
           <a:prstGeom prst="rect">
@@ -3598,21 +3639,21 @@
           <a:lstStyle/>
           <a:p>
             <a:pPr>
-              <a:defRPr sz="2600" b="1">
+              <a:defRPr sz="2400" b="1">
                 <a:solidFill>
                   <a:srgbClr val="FFFFFF"/>
                 </a:solidFill>
               </a:defRPr>
             </a:pPr>
             <a:r>
-              <a:t>Verdicts &amp; metric colors</a:t>
-            </a:r>
-          </a:p>
-        </p:txBody>
-      </p:sp>
-      <p:sp>
-        <p:nvSpPr>
-          <p:cNvPr id="4" name="TextBox 3"/>
+              <a:t>§6–§8 Review &amp; actions</a:t>
+            </a:r>
+          </a:p>
+        </p:txBody>
+      </p:sp>
+      <p:sp>
+        <p:nvSpPr>
+          <p:cNvPr id="5" name="TextBox 4"/>
           <p:cNvSpPr txBox="1"/>
           <p:nvPr/>
         </p:nvSpPr>
@@ -3634,88 +3675,106 @@
           <a:p>
             <a:pPr>
               <a:spcAft>
-                <a:spcPts val="800"/>
-              </a:spcAft>
-              <a:defRPr sz="1700">
+                <a:spcPts val="600"/>
+              </a:spcAft>
+              <a:defRPr sz="1600">
                 <a:solidFill>
                   <a:srgbClr val="0F172A"/>
                 </a:solidFill>
               </a:defRPr>
             </a:pPr>
             <a:r>
-              <a:t>Pass — Strong dev code and tests; minimal QA gaps</a:t>
-            </a:r>
-          </a:p>
-          <a:p>
-            <a:pPr>
-              <a:spcAft>
-                <a:spcPts val="800"/>
-              </a:spcAft>
-              <a:defRPr sz="1700">
+              <a:t>§6 Implementation review — strengths and gaps (High / Medium severity)</a:t>
+            </a:r>
+          </a:p>
+          <a:p>
+            <a:pPr>
+              <a:spcAft>
+                <a:spcPts val="600"/>
+              </a:spcAft>
+              <a:defRPr sz="1600">
                 <a:solidFill>
                   <a:srgbClr val="0F172A"/>
                 </a:solidFill>
               </a:defRPr>
             </a:pPr>
             <a:r>
-              <a:t>Pass with gaps — Code largely complete; QA handoff or dev test gaps remain</a:t>
-            </a:r>
-          </a:p>
-          <a:p>
-            <a:pPr>
-              <a:spcAft>
-                <a:spcPts val="800"/>
-              </a:spcAft>
-              <a:defRPr sz="1700">
+              <a:t>§7 Assumptions — inferred repo, branch, LADR scope needing confirmation</a:t>
+            </a:r>
+          </a:p>
+          <a:p>
+            <a:pPr>
+              <a:spcAft>
+                <a:spcPts val="600"/>
+              </a:spcAft>
+              <a:defRPr sz="1600">
                 <a:solidFill>
                   <a:srgbClr val="0F172A"/>
                 </a:solidFill>
               </a:defRPr>
             </a:pPr>
             <a:r>
-              <a:t>Fail — Significant missing implementation, tests, or AC contradictions</a:t>
-            </a:r>
-          </a:p>
-          <a:p>
-            <a:pPr>
-              <a:spcAft>
-                <a:spcPts val="800"/>
-              </a:spcAft>
-              <a:defRPr sz="1700">
+              <a:t>§8 Recommended actions — numbered dev and QA to-dos before release</a:t>
+            </a:r>
+          </a:p>
+          <a:p>
+            <a:pPr>
+              <a:spcAft>
+                <a:spcPts val="600"/>
+              </a:spcAft>
+              <a:defRPr sz="1600">
                 <a:solidFill>
                   <a:srgbClr val="0F172A"/>
                 </a:solidFill>
               </a:defRPr>
             </a:pPr>
-          </a:p>
-          <a:p>
-            <a:pPr>
-              <a:spcAft>
-                <a:spcPts val="800"/>
-              </a:spcAft>
-              <a:defRPr sz="1700">
-                <a:solidFill>
-                  <a:srgbClr val="0F172A"/>
-                </a:solidFill>
-              </a:defRPr>
-            </a:pPr>
-            <a:r>
-              <a:t>Metric colors:  Green ≥85%  ·  Amber 70–84.9%  ·  Red &lt;70%  ·  Gray NA</a:t>
-            </a:r>
-          </a:p>
-          <a:p>
-            <a:pPr>
-              <a:spcAft>
-                <a:spcPts val="800"/>
-              </a:spcAft>
-              <a:defRPr sz="1700">
-                <a:solidFill>
-                  <a:srgbClr val="0F172A"/>
-                </a:solidFill>
-              </a:defRPr>
-            </a:pPr>
-            <a:r>
-              <a:t>Report file:  reports/MSC-204417-05-26-2026-22-47-51-IST.html</a:t>
+            <a:r>
+              <a:t>Verdicts:</a:t>
+            </a:r>
+          </a:p>
+          <a:p>
+            <a:pPr lvl="1">
+              <a:spcAft>
+                <a:spcPts val="600"/>
+              </a:spcAft>
+              <a:defRPr sz="1400">
+                <a:solidFill>
+                  <a:srgbClr val="334155"/>
+                </a:solidFill>
+              </a:defRPr>
+            </a:pPr>
+            <a:r>
+              <a:t>  Pass — strong dev coverage, minimal QA gaps</a:t>
+            </a:r>
+          </a:p>
+          <a:p>
+            <a:pPr lvl="1">
+              <a:spcAft>
+                <a:spcPts val="600"/>
+              </a:spcAft>
+              <a:defRPr sz="1400">
+                <a:solidFill>
+                  <a:srgbClr val="334155"/>
+                </a:solidFill>
+              </a:defRPr>
+            </a:pPr>
+            <a:r>
+              <a:t>  Pass with gaps — code OK; QA handoff or test plan gaps remain</a:t>
+            </a:r>
+          </a:p>
+          <a:p>
+            <a:pPr lvl="1">
+              <a:spcAft>
+                <a:spcPts val="600"/>
+              </a:spcAft>
+              <a:defRPr sz="1400">
+                <a:solidFill>
+                  <a:srgbClr val="334155"/>
+                </a:solidFill>
+              </a:defRPr>
+            </a:pPr>
+            <a:r>
+              <a:t>  Fail — missing implementation, zero test plan coverage, or contradictions</a:t>
             </a:r>
           </a:p>
         </p:txBody>
@@ -3761,7 +3820,7 @@
             <a:avLst/>
           </a:prstGeom>
           <a:solidFill>
-            <a:srgbClr val="2563EB"/>
+            <a:srgbClr val="C2410C"/>
           </a:solidFill>
           <a:ln>
             <a:noFill/>
@@ -3812,14 +3871,14 @@
           <a:lstStyle/>
           <a:p>
             <a:pPr>
-              <a:defRPr sz="2600" b="1">
+              <a:defRPr sz="2400" b="1">
                 <a:solidFill>
                   <a:srgbClr val="FFFFFF"/>
                 </a:solidFill>
               </a:defRPr>
             </a:pPr>
             <a:r>
-              <a:t>Getting started</a:t>
+              <a:t>Configuration required</a:t>
             </a:r>
           </a:p>
         </p:txBody>
@@ -3854,7 +3913,7 @@
               </a:defRPr>
             </a:pPr>
             <a:r>
-              <a:t>Pegasus QA Agents Lab</a:t>
+              <a:t>One-time per teammate (~10 min)</a:t>
             </a:r>
           </a:p>
         </p:txBody>
@@ -3883,88 +3942,1264 @@
           <a:p>
             <a:pPr>
               <a:spcAft>
-                <a:spcPts val="800"/>
-              </a:spcAft>
-              <a:defRPr sz="1700">
+                <a:spcPts val="600"/>
+              </a:spcAft>
+              <a:defRPr sz="1600">
                 <a:solidFill>
                   <a:srgbClr val="0F172A"/>
                 </a:solidFill>
               </a:defRPr>
             </a:pPr>
             <a:r>
+              <a:t>Required for all MSC agents:</a:t>
+            </a:r>
+          </a:p>
+          <a:p>
+            <a:pPr lvl="1">
+              <a:spcAft>
+                <a:spcPts val="600"/>
+              </a:spcAft>
+              <a:defRPr sz="1400">
+                <a:solidFill>
+                  <a:srgbClr val="334155"/>
+                </a:solidFill>
+              </a:defRPr>
+            </a:pPr>
+            <a:r>
+              <a:t>  • Cursor IDE with Agents · Clone pegasus-qa-agents-lab · Open as workspace</a:t>
+            </a:r>
+          </a:p>
+          <a:p>
+            <a:pPr lvl="1">
+              <a:spcAft>
+                <a:spcPts val="600"/>
+              </a:spcAft>
+              <a:defRPr sz="1400">
+                <a:solidFill>
+                  <a:srgbClr val="334155"/>
+                </a:solidFill>
+              </a:defRPr>
+            </a:pPr>
+            <a:r>
+              <a:t>  • Atlassian MCP authenticated for wbdstreaming.atlassian.net</a:t>
+            </a:r>
+          </a:p>
+          <a:p>
+            <a:pPr lvl="1">
+              <a:spcAft>
+                <a:spcPts val="600"/>
+              </a:spcAft>
+              <a:defRPr sz="1400">
+                <a:solidFill>
+                  <a:srgbClr val="334155"/>
+                </a:solidFill>
+              </a:defRPr>
+            </a:pPr>
+            <a:r>
+              <a:t>  • Python 3.10+ · pip install -r requirements.txt</a:t>
+            </a:r>
+          </a:p>
+          <a:p>
+            <a:pPr>
+              <a:spcAft>
+                <a:spcPts val="600"/>
+              </a:spcAft>
+              <a:defRPr sz="1600">
+                <a:solidFill>
+                  <a:srgbClr val="0F172A"/>
+                </a:solidFill>
+              </a:defRPr>
+            </a:pPr>
+            <a:r>
+              <a:t>Additional for coverage validator:</a:t>
+            </a:r>
+          </a:p>
+          <a:p>
+            <a:pPr lvl="1">
+              <a:spcAft>
+                <a:spcPts val="600"/>
+              </a:spcAft>
+              <a:defRPr sz="1400">
+                <a:solidFill>
+                  <a:srgbClr val="334155"/>
+                </a:solidFill>
+              </a:defRPr>
+            </a:pPr>
+            <a:r>
+              <a:t>  • gh CLI authenticated (gh auth login)</a:t>
+            </a:r>
+          </a:p>
+          <a:p>
+            <a:pPr lvl="1">
+              <a:spcAft>
+                <a:spcPts val="600"/>
+              </a:spcAft>
+              <a:defRPr sz="1400">
+                <a:solidFill>
+                  <a:srgbClr val="334155"/>
+                </a:solidFill>
+              </a:defRPr>
+            </a:pPr>
+            <a:r>
+              <a:t>  • python scripts/install_coverage_validator_permissions.py</a:t>
+            </a:r>
+          </a:p>
+          <a:p>
+            <a:pPr lvl="1">
+              <a:spcAft>
+                <a:spcPts val="600"/>
+              </a:spcAft>
+              <a:defRPr sz="1400">
+                <a:solidFill>
+                  <a:srgbClr val="334155"/>
+                </a:solidFill>
+              </a:defRPr>
+            </a:pPr>
+            <a:r>
+              <a:t>  • Cursor Settings → Agents → Auto-Run → Allowlist</a:t>
+            </a:r>
+          </a:p>
+          <a:p>
+            <a:pPr>
+              <a:spcAft>
+                <a:spcPts val="600"/>
+              </a:spcAft>
+              <a:defRPr sz="1600">
+                <a:solidFill>
+                  <a:srgbClr val="0F172A"/>
+                </a:solidFill>
+              </a:defRPr>
+            </a:pPr>
+            <a:r>
+              <a:t>Recommended when Jira has test plan attachments:</a:t>
+            </a:r>
+          </a:p>
+          <a:p>
+            <a:pPr lvl="1">
+              <a:spcAft>
+                <a:spcPts val="600"/>
+              </a:spcAft>
+              <a:defRPr sz="1400">
+                <a:solidFill>
+                  <a:srgbClr val="334155"/>
+                </a:solidFill>
+              </a:defRPr>
+            </a:pPr>
+            <a:r>
+              <a:t>  • .env with ATLASSIAN_EMAIL + ATLASSIAN_API_TOKEN (from .env.example)</a:t>
+            </a:r>
+          </a:p>
+        </p:txBody>
+      </p:sp>
+    </p:spTree>
+  </p:cSld>
+  <p:clrMapOvr>
+    <a:masterClrMapping/>
+  </p:clrMapOvr>
+</p:sld>
+</file>
+
+<file path=ppt/slides/slide13.xml><?xml version="1.0" encoding="utf-8"?>
+<p:sld xmlns:a="http://schemas.openxmlformats.org/drawingml/2006/main" xmlns:p="http://schemas.openxmlformats.org/presentationml/2006/main" xmlns:r="http://schemas.openxmlformats.org/officeDocument/2006/relationships">
+  <p:cSld>
+    <p:bg>
+      <p:bgPr>
+        <a:solidFill>
+          <a:srgbClr val="FFFFFF"/>
+        </a:solidFill>
+        <a:effectLst/>
+      </p:bgPr>
+    </p:bg>
+    <p:spTree>
+      <p:nvGrpSpPr>
+        <p:cNvPr id="1" name=""/>
+        <p:cNvGrpSpPr/>
+        <p:nvPr/>
+      </p:nvGrpSpPr>
+      <p:grpSpPr/>
+      <p:sp>
+        <p:nvSpPr>
+          <p:cNvPr id="2" name="Rectangle 1"/>
+          <p:cNvSpPr/>
+          <p:nvPr/>
+        </p:nvSpPr>
+        <p:spPr>
+          <a:xfrm>
+            <a:off x="0" y="0"/>
+            <a:ext cx="9144000" cy="960120"/>
+          </a:xfrm>
+          <a:prstGeom prst="rect">
+            <a:avLst/>
+          </a:prstGeom>
+          <a:solidFill>
+            <a:srgbClr val="334155"/>
+          </a:solidFill>
+          <a:ln>
+            <a:noFill/>
+          </a:ln>
+        </p:spPr>
+        <p:style>
+          <a:lnRef idx="1">
+            <a:schemeClr val="accent1"/>
+          </a:lnRef>
+          <a:fillRef idx="3">
+            <a:schemeClr val="accent1"/>
+          </a:fillRef>
+          <a:effectRef idx="2">
+            <a:schemeClr val="accent1"/>
+          </a:effectRef>
+          <a:fontRef idx="minor">
+            <a:schemeClr val="lt1"/>
+          </a:fontRef>
+        </p:style>
+        <p:txBody>
+          <a:bodyPr rtlCol="0" anchor="ctr"/>
+          <a:lstStyle/>
+          <a:p>
+            <a:pPr algn="ctr"/>
+          </a:p>
+        </p:txBody>
+      </p:sp>
+      <p:sp>
+        <p:nvSpPr>
+          <p:cNvPr id="3" name="TextBox 2"/>
+          <p:cNvSpPr txBox="1"/>
+          <p:nvPr/>
+        </p:nvSpPr>
+        <p:spPr>
+          <a:xfrm>
+            <a:off x="411480" y="164592"/>
+            <a:ext cx="7772400" cy="640080"/>
+          </a:xfrm>
+          <a:prstGeom prst="rect">
+            <a:avLst/>
+          </a:prstGeom>
+          <a:noFill/>
+        </p:spPr>
+        <p:txBody>
+          <a:bodyPr wrap="none">
+            <a:spAutoFit/>
+          </a:bodyPr>
+          <a:lstStyle/>
+          <a:p>
+            <a:pPr>
+              <a:defRPr sz="2400" b="1">
+                <a:solidFill>
+                  <a:srgbClr val="FFFFFF"/>
+                </a:solidFill>
+              </a:defRPr>
+            </a:pPr>
+            <a:r>
+              <a:t>Config: workspace defaults</a:t>
+            </a:r>
+          </a:p>
+        </p:txBody>
+      </p:sp>
+      <p:sp>
+        <p:nvSpPr>
+          <p:cNvPr id="4" name="TextBox 3"/>
+          <p:cNvSpPr txBox="1"/>
+          <p:nvPr/>
+        </p:nvSpPr>
+        <p:spPr>
+          <a:xfrm>
+            <a:off x="502920" y="1051560"/>
+            <a:ext cx="8046720" cy="365760"/>
+          </a:xfrm>
+          <a:prstGeom prst="rect">
+            <a:avLst/>
+          </a:prstGeom>
+          <a:noFill/>
+        </p:spPr>
+        <p:txBody>
+          <a:bodyPr wrap="none">
+            <a:spAutoFit/>
+          </a:bodyPr>
+          <a:lstStyle/>
+          <a:p>
+            <a:pPr>
+              <a:defRPr sz="1300" i="1">
+                <a:solidFill>
+                  <a:srgbClr val="64748B"/>
+                </a:solidFill>
+              </a:defRPr>
+            </a:pPr>
+            <a:r>
+              <a:t>.coverage-validator.defaults.json (gitignored)</a:t>
+            </a:r>
+          </a:p>
+        </p:txBody>
+      </p:sp>
+      <p:sp>
+        <p:nvSpPr>
+          <p:cNvPr id="5" name="TextBox 4"/>
+          <p:cNvSpPr txBox="1"/>
+          <p:nvPr/>
+        </p:nvSpPr>
+        <p:spPr>
+          <a:xfrm>
+            <a:off x="502920" y="1417320"/>
+            <a:ext cx="8046720" cy="5120640"/>
+          </a:xfrm>
+          <a:prstGeom prst="rect">
+            <a:avLst/>
+          </a:prstGeom>
+          <a:noFill/>
+        </p:spPr>
+        <p:txBody>
+          <a:bodyPr wrap="square">
+            <a:spAutoFit/>
+          </a:bodyPr>
+          <a:lstStyle/>
+          <a:p>
+            <a:pPr>
+              <a:spcAft>
+                <a:spcPts val="600"/>
+              </a:spcAft>
+              <a:defRPr sz="1600">
+                <a:solidFill>
+                  <a:srgbClr val="0F172A"/>
+                </a:solidFill>
+              </a:defRPr>
+            </a:pPr>
+            <a:r>
+              <a:t>Copy from .cursor/skills/msc-code-coverage-validator/validator.defaults.example.json</a:t>
+            </a:r>
+          </a:p>
+          <a:p>
+            <a:pPr>
+              <a:spcAft>
+                <a:spcPts val="600"/>
+              </a:spcAft>
+              <a:defRPr sz="1600">
+                <a:solidFill>
+                  <a:srgbClr val="0F172A"/>
+                </a:solidFill>
+              </a:defRPr>
+            </a:pPr>
+            <a:r>
+              <a:t>Key fields:</a:t>
+            </a:r>
+          </a:p>
+          <a:p>
+            <a:pPr lvl="1">
+              <a:spcAft>
+                <a:spcPts val="600"/>
+              </a:spcAft>
+              <a:defRPr sz="1400">
+                <a:solidFill>
+                  <a:srgbClr val="334155"/>
+                </a:solidFill>
+              </a:defRPr>
+            </a:pPr>
+            <a:r>
+              <a:t>  repo — default GitHub org/repo (e.g. wbd-msc/pegasus-pick-genie)</a:t>
+            </a:r>
+          </a:p>
+          <a:p>
+            <a:pPr lvl="1">
+              <a:spcAft>
+                <a:spcPts val="600"/>
+              </a:spcAft>
+              <a:defRPr sz="1400">
+                <a:solidFill>
+                  <a:srgbClr val="334155"/>
+                </a:solidFill>
+              </a:defRPr>
+            </a:pPr>
+            <a:r>
+              <a:t>  timezone / timezoneLabel — report filename suffix (IST, EST)</a:t>
+            </a:r>
+          </a:p>
+          <a:p>
+            <a:pPr lvl="1">
+              <a:spcAft>
+                <a:spcPts val="600"/>
+              </a:spcAft>
+              <a:defRPr sz="1400">
+                <a:solidFill>
+                  <a:srgbClr val="334155"/>
+                </a:solidFill>
+              </a:defRPr>
+            </a:pPr>
+            <a:r>
+              <a:t>  testPlanPath / testPlanSheet — local Domino Excel when Jira references SharePoint</a:t>
+            </a:r>
+          </a:p>
+          <a:p>
+            <a:pPr lvl="1">
+              <a:spcAft>
+                <a:spcPts val="600"/>
+              </a:spcAft>
+              <a:defRPr sz="1400">
+                <a:solidFill>
+                  <a:srgbClr val="334155"/>
+                </a:solidFill>
+              </a:defRPr>
+            </a:pPr>
+            <a:r>
+              <a:t>  mode: auto · writeReport: true · useCache: true · cacheMaxAgeHours: 24</a:t>
+            </a:r>
+          </a:p>
+          <a:p>
+            <a:pPr>
+              <a:spcAft>
+                <a:spcPts val="600"/>
+              </a:spcAft>
+              <a:defRPr sz="1600">
+                <a:solidFill>
+                  <a:srgbClr val="0F172A"/>
+                </a:solidFill>
+              </a:defRPr>
+            </a:pPr>
+            <a:r>
+              <a:t>Manifest reuse: reports/.cache/{KEY}-manifest.json stores last report path + PR URLs</a:t>
+            </a:r>
+          </a:p>
+        </p:txBody>
+      </p:sp>
+    </p:spTree>
+  </p:cSld>
+  <p:clrMapOvr>
+    <a:masterClrMapping/>
+  </p:clrMapOvr>
+</p:sld>
+</file>
+
+<file path=ppt/slides/slide14.xml><?xml version="1.0" encoding="utf-8"?>
+<p:sld xmlns:a="http://schemas.openxmlformats.org/drawingml/2006/main" xmlns:p="http://schemas.openxmlformats.org/presentationml/2006/main" xmlns:r="http://schemas.openxmlformats.org/officeDocument/2006/relationships">
+  <p:cSld>
+    <p:bg>
+      <p:bgPr>
+        <a:solidFill>
+          <a:srgbClr val="FFFFFF"/>
+        </a:solidFill>
+        <a:effectLst/>
+      </p:bgPr>
+    </p:bg>
+    <p:spTree>
+      <p:nvGrpSpPr>
+        <p:cNvPr id="1" name=""/>
+        <p:cNvGrpSpPr/>
+        <p:nvPr/>
+      </p:nvGrpSpPr>
+      <p:grpSpPr/>
+      <p:sp>
+        <p:nvSpPr>
+          <p:cNvPr id="2" name="Rectangle 1"/>
+          <p:cNvSpPr/>
+          <p:nvPr/>
+        </p:nvSpPr>
+        <p:spPr>
+          <a:xfrm>
+            <a:off x="0" y="0"/>
+            <a:ext cx="9144000" cy="960120"/>
+          </a:xfrm>
+          <a:prstGeom prst="rect">
+            <a:avLst/>
+          </a:prstGeom>
+          <a:solidFill>
+            <a:srgbClr val="2563EB"/>
+          </a:solidFill>
+          <a:ln>
+            <a:noFill/>
+          </a:ln>
+        </p:spPr>
+        <p:style>
+          <a:lnRef idx="1">
+            <a:schemeClr val="accent1"/>
+          </a:lnRef>
+          <a:fillRef idx="3">
+            <a:schemeClr val="accent1"/>
+          </a:fillRef>
+          <a:effectRef idx="2">
+            <a:schemeClr val="accent1"/>
+          </a:effectRef>
+          <a:fontRef idx="minor">
+            <a:schemeClr val="lt1"/>
+          </a:fontRef>
+        </p:style>
+        <p:txBody>
+          <a:bodyPr rtlCol="0" anchor="ctr"/>
+          <a:lstStyle/>
+          <a:p>
+            <a:pPr algn="ctr"/>
+          </a:p>
+        </p:txBody>
+      </p:sp>
+      <p:sp>
+        <p:nvSpPr>
+          <p:cNvPr id="3" name="TextBox 2"/>
+          <p:cNvSpPr txBox="1"/>
+          <p:nvPr/>
+        </p:nvSpPr>
+        <p:spPr>
+          <a:xfrm>
+            <a:off x="411480" y="164592"/>
+            <a:ext cx="7772400" cy="640080"/>
+          </a:xfrm>
+          <a:prstGeom prst="rect">
+            <a:avLst/>
+          </a:prstGeom>
+          <a:noFill/>
+        </p:spPr>
+        <p:txBody>
+          <a:bodyPr wrap="none">
+            <a:spAutoFit/>
+          </a:bodyPr>
+          <a:lstStyle/>
+          <a:p>
+            <a:pPr>
+              <a:defRPr sz="2400" b="1">
+                <a:solidFill>
+                  <a:srgbClr val="FFFFFF"/>
+                </a:solidFill>
+              </a:defRPr>
+            </a:pPr>
+            <a:r>
+              <a:t>Config: permissions &amp; scripts</a:t>
+            </a:r>
+          </a:p>
+        </p:txBody>
+      </p:sp>
+      <p:sp>
+        <p:nvSpPr>
+          <p:cNvPr id="4" name="TextBox 3"/>
+          <p:cNvSpPr txBox="1"/>
+          <p:nvPr/>
+        </p:nvSpPr>
+        <p:spPr>
+          <a:xfrm>
+            <a:off x="502920" y="1051560"/>
+            <a:ext cx="8046720" cy="365760"/>
+          </a:xfrm>
+          <a:prstGeom prst="rect">
+            <a:avLst/>
+          </a:prstGeom>
+          <a:noFill/>
+        </p:spPr>
+        <p:txBody>
+          <a:bodyPr wrap="none">
+            <a:spAutoFit/>
+          </a:bodyPr>
+          <a:lstStyle/>
+          <a:p>
+            <a:pPr>
+              <a:defRPr sz="1300" i="1">
+                <a:solidFill>
+                  <a:srgbClr val="64748B"/>
+                </a:solidFill>
+              </a:defRPr>
+            </a:pPr>
+            <a:r>
+              <a:t>Avoid Allow/Run prompts every run</a:t>
+            </a:r>
+          </a:p>
+        </p:txBody>
+      </p:sp>
+      <p:sp>
+        <p:nvSpPr>
+          <p:cNvPr id="5" name="TextBox 4"/>
+          <p:cNvSpPr txBox="1"/>
+          <p:nvPr/>
+        </p:nvSpPr>
+        <p:spPr>
+          <a:xfrm>
+            <a:off x="502920" y="1417320"/>
+            <a:ext cx="8046720" cy="5120640"/>
+          </a:xfrm>
+          <a:prstGeom prst="rect">
+            <a:avLst/>
+          </a:prstGeom>
+          <a:noFill/>
+        </p:spPr>
+        <p:txBody>
+          <a:bodyPr wrap="square">
+            <a:spAutoFit/>
+          </a:bodyPr>
+          <a:lstStyle/>
+          <a:p>
+            <a:pPr>
+              <a:spcAft>
+                <a:spcPts val="600"/>
+              </a:spcAft>
+              <a:defRPr sz="1600">
+                <a:solidFill>
+                  <a:srgbClr val="0F172A"/>
+                </a:solidFill>
+              </a:defRPr>
+            </a:pPr>
+            <a:r>
+              <a:t>install_coverage_validator_permissions.py merges into ~/.cursor/permissions.json:</a:t>
+            </a:r>
+          </a:p>
+          <a:p>
+            <a:pPr lvl="1">
+              <a:spcAft>
+                <a:spcPts val="600"/>
+              </a:spcAft>
+              <a:defRPr sz="1400">
+                <a:solidFill>
+                  <a:srgbClr val="334155"/>
+                </a:solidFill>
+              </a:defRPr>
+            </a:pPr>
+            <a:r>
+              <a:t>  MCP: user-atlassian:getJiraIssue, getJiraIssueRemoteIssueLinks, …</a:t>
+            </a:r>
+          </a:p>
+          <a:p>
+            <a:pPr lvl="1">
+              <a:spcAft>
+                <a:spcPts val="600"/>
+              </a:spcAft>
+              <a:defRPr sz="1400">
+                <a:solidFill>
+                  <a:srgbClr val="334155"/>
+                </a:solidFill>
+              </a:defRPr>
+            </a:pPr>
+            <a:r>
+              <a:t>  Shell: gh, prefetch_coverage_inputs.py, fetch_jira_testplan.py, mkdir</a:t>
+            </a:r>
+          </a:p>
+          <a:p>
+            <a:pPr>
+              <a:spcAft>
+                <a:spcPts val="600"/>
+              </a:spcAft>
+              <a:defRPr sz="1600">
+                <a:solidFill>
+                  <a:srgbClr val="0F172A"/>
+                </a:solidFill>
+              </a:defRPr>
+            </a:pPr>
+            <a:r>
+              <a:t>Supporting scripts (no manual gh per call):</a:t>
+            </a:r>
+          </a:p>
+          <a:p>
+            <a:pPr lvl="1">
+              <a:spcAft>
+                <a:spcPts val="600"/>
+              </a:spcAft>
+              <a:defRPr sz="1400">
+                <a:solidFill>
+                  <a:srgbClr val="334155"/>
+                </a:solidFill>
+              </a:defRPr>
+            </a:pPr>
+            <a:r>
+              <a:t>  fetch_jira_testplan.py — download QMetry attachment, parse scenarios</a:t>
+            </a:r>
+          </a:p>
+          <a:p>
+            <a:pPr lvl="1">
+              <a:spcAft>
+                <a:spcPts val="600"/>
+              </a:spcAft>
+              <a:defRPr sz="1400">
+                <a:solidFill>
+                  <a:srgbClr val="334155"/>
+                </a:solidFill>
+              </a:defRPr>
+            </a:pPr>
+            <a:r>
+              <a:t>  prefetch_coverage_inputs.py — batch PR view/diff/checks to cache</a:t>
+            </a:r>
+          </a:p>
+          <a:p>
+            <a:pPr lvl="1">
+              <a:spcAft>
+                <a:spcPts val="600"/>
+              </a:spcAft>
+              <a:defRPr sz="1400">
+                <a:solidFill>
+                  <a:srgbClr val="334155"/>
+                </a:solidFill>
+              </a:defRPr>
+            </a:pPr>
+            <a:r>
+              <a:t>  fetch_coverage_github.py — branch compare when no PR linked</a:t>
+            </a:r>
+          </a:p>
+          <a:p>
+            <a:pPr lvl="1">
+              <a:spcAft>
+                <a:spcPts val="600"/>
+              </a:spcAft>
+              <a:defRPr sz="1400">
+                <a:solidFill>
+                  <a:srgbClr val="334155"/>
+                </a:solidFill>
+              </a:defRPr>
+            </a:pPr>
+            <a:r>
+              <a:t>  verify_jira_credentials.py — test .env against an issue</a:t>
+            </a:r>
+          </a:p>
+        </p:txBody>
+      </p:sp>
+    </p:spTree>
+  </p:cSld>
+  <p:clrMapOvr>
+    <a:masterClrMapping/>
+  </p:clrMapOvr>
+</p:sld>
+</file>
+
+<file path=ppt/slides/slide15.xml><?xml version="1.0" encoding="utf-8"?>
+<p:sld xmlns:a="http://schemas.openxmlformats.org/drawingml/2006/main" xmlns:p="http://schemas.openxmlformats.org/presentationml/2006/main" xmlns:r="http://schemas.openxmlformats.org/officeDocument/2006/relationships">
+  <p:cSld>
+    <p:bg>
+      <p:bgPr>
+        <a:solidFill>
+          <a:srgbClr val="FFFFFF"/>
+        </a:solidFill>
+        <a:effectLst/>
+      </p:bgPr>
+    </p:bg>
+    <p:spTree>
+      <p:nvGrpSpPr>
+        <p:cNvPr id="1" name=""/>
+        <p:cNvGrpSpPr/>
+        <p:nvPr/>
+      </p:nvGrpSpPr>
+      <p:grpSpPr/>
+      <p:sp>
+        <p:nvSpPr>
+          <p:cNvPr id="2" name="Rectangle 1"/>
+          <p:cNvSpPr/>
+          <p:nvPr/>
+        </p:nvSpPr>
+        <p:spPr>
+          <a:xfrm>
+            <a:off x="0" y="0"/>
+            <a:ext cx="9144000" cy="960120"/>
+          </a:xfrm>
+          <a:prstGeom prst="rect">
+            <a:avLst/>
+          </a:prstGeom>
+          <a:solidFill>
+            <a:srgbClr val="15803D"/>
+          </a:solidFill>
+          <a:ln>
+            <a:noFill/>
+          </a:ln>
+        </p:spPr>
+        <p:style>
+          <a:lnRef idx="1">
+            <a:schemeClr val="accent1"/>
+          </a:lnRef>
+          <a:fillRef idx="3">
+            <a:schemeClr val="accent1"/>
+          </a:fillRef>
+          <a:effectRef idx="2">
+            <a:schemeClr val="accent1"/>
+          </a:effectRef>
+          <a:fontRef idx="minor">
+            <a:schemeClr val="lt1"/>
+          </a:fontRef>
+        </p:style>
+        <p:txBody>
+          <a:bodyPr rtlCol="0" anchor="ctr"/>
+          <a:lstStyle/>
+          <a:p>
+            <a:pPr algn="ctr"/>
+          </a:p>
+        </p:txBody>
+      </p:sp>
+      <p:sp>
+        <p:nvSpPr>
+          <p:cNvPr id="3" name="TextBox 2"/>
+          <p:cNvSpPr txBox="1"/>
+          <p:nvPr/>
+        </p:nvSpPr>
+        <p:spPr>
+          <a:xfrm>
+            <a:off x="411480" y="164592"/>
+            <a:ext cx="7772400" cy="640080"/>
+          </a:xfrm>
+          <a:prstGeom prst="rect">
+            <a:avLst/>
+          </a:prstGeom>
+          <a:noFill/>
+        </p:spPr>
+        <p:txBody>
+          <a:bodyPr wrap="none">
+            <a:spAutoFit/>
+          </a:bodyPr>
+          <a:lstStyle/>
+          <a:p>
+            <a:pPr>
+              <a:defRPr sz="2400" b="1">
+                <a:solidFill>
+                  <a:srgbClr val="FFFFFF"/>
+                </a:solidFill>
+              </a:defRPr>
+            </a:pPr>
+            <a:r>
+              <a:t>Sample outcomes</a:t>
+            </a:r>
+          </a:p>
+        </p:txBody>
+      </p:sp>
+      <p:sp>
+        <p:nvSpPr>
+          <p:cNvPr id="4" name="TextBox 3"/>
+          <p:cNvSpPr txBox="1"/>
+          <p:nvPr/>
+        </p:nvSpPr>
+        <p:spPr>
+          <a:xfrm>
+            <a:off x="502920" y="1051560"/>
+            <a:ext cx="8046720" cy="365760"/>
+          </a:xfrm>
+          <a:prstGeom prst="rect">
+            <a:avLst/>
+          </a:prstGeom>
+          <a:noFill/>
+        </p:spPr>
+        <p:txBody>
+          <a:bodyPr wrap="none">
+            <a:spAutoFit/>
+          </a:bodyPr>
+          <a:lstStyle/>
+          <a:p>
+            <a:pPr>
+              <a:defRPr sz="1300" i="1">
+                <a:solidFill>
+                  <a:srgbClr val="64748B"/>
+                </a:solidFill>
+              </a:defRPr>
+            </a:pPr>
+            <a:r>
+              <a:t>Real MSC examples</a:t>
+            </a:r>
+          </a:p>
+        </p:txBody>
+      </p:sp>
+      <p:sp>
+        <p:nvSpPr>
+          <p:cNvPr id="5" name="TextBox 4"/>
+          <p:cNvSpPr txBox="1"/>
+          <p:nvPr/>
+        </p:nvSpPr>
+        <p:spPr>
+          <a:xfrm>
+            <a:off x="502920" y="1417320"/>
+            <a:ext cx="8046720" cy="5120640"/>
+          </a:xfrm>
+          <a:prstGeom prst="rect">
+            <a:avLst/>
+          </a:prstGeom>
+          <a:noFill/>
+        </p:spPr>
+        <p:txBody>
+          <a:bodyPr wrap="square">
+            <a:spAutoFit/>
+          </a:bodyPr>
+          <a:lstStyle/>
+          <a:p>
+            <a:pPr>
+              <a:spcAft>
+                <a:spcPts val="600"/>
+              </a:spcAft>
+              <a:defRPr sz="1600">
+                <a:solidFill>
+                  <a:srgbClr val="0F172A"/>
+                </a:solidFill>
+              </a:defRPr>
+            </a:pPr>
+            <a:r>
+              <a:t>MSC-205625 (Bug, Ready for Release)</a:t>
+            </a:r>
+          </a:p>
+          <a:p>
+            <a:pPr lvl="1">
+              <a:spcAft>
+                <a:spcPts val="600"/>
+              </a:spcAft>
+              <a:defRPr sz="1400">
+                <a:solidFill>
+                  <a:srgbClr val="334155"/>
+                </a:solidFill>
+              </a:defRPr>
+            </a:pPr>
+            <a:r>
+              <a:t>  • 100% dev code · 75% dev tests · 75% test plan AC · Pass with gaps</a:t>
+            </a:r>
+          </a:p>
+          <a:p>
+            <a:pPr lvl="1">
+              <a:spcAft>
+                <a:spcPts val="600"/>
+              </a:spcAft>
+              <a:defRPr sz="1400">
+                <a:solidFill>
+                  <a:srgbClr val="334155"/>
+                </a:solidFill>
+              </a:defRPr>
+            </a:pPr>
+            <a:r>
+              <a:t>  • PR #161 pick-genie passport fix; 5 Domino scenarios; R4 SIT evidence pending</a:t>
+            </a:r>
+          </a:p>
+          <a:p>
+            <a:pPr>
+              <a:spcAft>
+                <a:spcPts val="600"/>
+              </a:spcAft>
+              <a:defRPr sz="1600">
+                <a:solidFill>
+                  <a:srgbClr val="0F172A"/>
+                </a:solidFill>
+              </a:defRPr>
+            </a:pPr>
+            <a:r>
+              <a:t>MSC-204417 (Story, In QA)</a:t>
+            </a:r>
+          </a:p>
+          <a:p>
+            <a:pPr lvl="1">
+              <a:spcAft>
+                <a:spcPts val="600"/>
+              </a:spcAft>
+              <a:defRPr sz="1400">
+                <a:solidFill>
+                  <a:srgbClr val="334155"/>
+                </a:solidFill>
+              </a:defRPr>
+            </a:pPr>
+            <a:r>
+              <a:t>  • 100% dev code · 83% dev tests · No test plan attachment (NA)</a:t>
+            </a:r>
+          </a:p>
+          <a:p>
+            <a:pPr lvl="1">
+              <a:spcAft>
+                <a:spcPts val="600"/>
+              </a:spcAft>
+              <a:defRPr sz="1400">
+                <a:solidFill>
+                  <a:srgbClr val="334155"/>
+                </a:solidFill>
+              </a:defRPr>
+            </a:pPr>
+            <a:r>
+              <a:t>  • develop branch only; Monitor E2E + STATUS_ERROR 9000 → QA handoff</a:t>
+            </a:r>
+          </a:p>
+          <a:p>
+            <a:pPr>
+              <a:spcAft>
+                <a:spcPts val="600"/>
+              </a:spcAft>
+              <a:defRPr sz="1600">
+                <a:solidFill>
+                  <a:srgbClr val="0F172A"/>
+                </a:solidFill>
+              </a:defRPr>
+            </a:pPr>
+            <a:r>
+              <a:t>Report path example:</a:t>
+            </a:r>
+          </a:p>
+          <a:p>
+            <a:pPr lvl="1">
+              <a:spcAft>
+                <a:spcPts val="600"/>
+              </a:spcAft>
+              <a:defRPr sz="1400">
+                <a:solidFill>
+                  <a:srgbClr val="334155"/>
+                </a:solidFill>
+              </a:defRPr>
+            </a:pPr>
+            <a:r>
+              <a:t>  reports/MSC-205625-05-27-2026-14-56-29-IST.html</a:t>
+            </a:r>
+          </a:p>
+        </p:txBody>
+      </p:sp>
+    </p:spTree>
+  </p:cSld>
+  <p:clrMapOvr>
+    <a:masterClrMapping/>
+  </p:clrMapOvr>
+</p:sld>
+</file>
+
+<file path=ppt/slides/slide16.xml><?xml version="1.0" encoding="utf-8"?>
+<p:sld xmlns:a="http://schemas.openxmlformats.org/drawingml/2006/main" xmlns:p="http://schemas.openxmlformats.org/presentationml/2006/main" xmlns:r="http://schemas.openxmlformats.org/officeDocument/2006/relationships">
+  <p:cSld>
+    <p:bg>
+      <p:bgPr>
+        <a:solidFill>
+          <a:srgbClr val="FFFFFF"/>
+        </a:solidFill>
+        <a:effectLst/>
+      </p:bgPr>
+    </p:bg>
+    <p:spTree>
+      <p:nvGrpSpPr>
+        <p:cNvPr id="1" name=""/>
+        <p:cNvGrpSpPr/>
+        <p:nvPr/>
+      </p:nvGrpSpPr>
+      <p:grpSpPr/>
+      <p:sp>
+        <p:nvSpPr>
+          <p:cNvPr id="2" name="Rectangle 1"/>
+          <p:cNvSpPr/>
+          <p:nvPr/>
+        </p:nvSpPr>
+        <p:spPr>
+          <a:xfrm>
+            <a:off x="0" y="0"/>
+            <a:ext cx="9144000" cy="960120"/>
+          </a:xfrm>
+          <a:prstGeom prst="rect">
+            <a:avLst/>
+          </a:prstGeom>
+          <a:solidFill>
+            <a:srgbClr val="1E40AF"/>
+          </a:solidFill>
+          <a:ln>
+            <a:noFill/>
+          </a:ln>
+        </p:spPr>
+        <p:style>
+          <a:lnRef idx="1">
+            <a:schemeClr val="accent1"/>
+          </a:lnRef>
+          <a:fillRef idx="3">
+            <a:schemeClr val="accent1"/>
+          </a:fillRef>
+          <a:effectRef idx="2">
+            <a:schemeClr val="accent1"/>
+          </a:effectRef>
+          <a:fontRef idx="minor">
+            <a:schemeClr val="lt1"/>
+          </a:fontRef>
+        </p:style>
+        <p:txBody>
+          <a:bodyPr rtlCol="0" anchor="ctr"/>
+          <a:lstStyle/>
+          <a:p>
+            <a:pPr algn="ctr"/>
+          </a:p>
+        </p:txBody>
+      </p:sp>
+      <p:sp>
+        <p:nvSpPr>
+          <p:cNvPr id="3" name="TextBox 2"/>
+          <p:cNvSpPr txBox="1"/>
+          <p:nvPr/>
+        </p:nvSpPr>
+        <p:spPr>
+          <a:xfrm>
+            <a:off x="411480" y="164592"/>
+            <a:ext cx="7772400" cy="640080"/>
+          </a:xfrm>
+          <a:prstGeom prst="rect">
+            <a:avLst/>
+          </a:prstGeom>
+          <a:noFill/>
+        </p:spPr>
+        <p:txBody>
+          <a:bodyPr wrap="none">
+            <a:spAutoFit/>
+          </a:bodyPr>
+          <a:lstStyle/>
+          <a:p>
+            <a:pPr>
+              <a:defRPr sz="2400" b="1">
+                <a:solidFill>
+                  <a:srgbClr val="FFFFFF"/>
+                </a:solidFill>
+              </a:defRPr>
+            </a:pPr>
+            <a:r>
+              <a:t>Getting started</a:t>
+            </a:r>
+          </a:p>
+        </p:txBody>
+      </p:sp>
+      <p:sp>
+        <p:nvSpPr>
+          <p:cNvPr id="4" name="TextBox 3"/>
+          <p:cNvSpPr txBox="1"/>
+          <p:nvPr/>
+        </p:nvSpPr>
+        <p:spPr>
+          <a:xfrm>
+            <a:off x="502920" y="1051560"/>
+            <a:ext cx="8046720" cy="365760"/>
+          </a:xfrm>
+          <a:prstGeom prst="rect">
+            <a:avLst/>
+          </a:prstGeom>
+          <a:noFill/>
+        </p:spPr>
+        <p:txBody>
+          <a:bodyPr wrap="none">
+            <a:spAutoFit/>
+          </a:bodyPr>
+          <a:lstStyle/>
+          <a:p>
+            <a:pPr>
+              <a:defRPr sz="1300" i="1">
+                <a:solidFill>
+                  <a:srgbClr val="64748B"/>
+                </a:solidFill>
+              </a:defRPr>
+            </a:pPr>
+            <a:r>
+              <a:t>Commands to run today</a:t>
+            </a:r>
+          </a:p>
+        </p:txBody>
+      </p:sp>
+      <p:sp>
+        <p:nvSpPr>
+          <p:cNvPr id="5" name="TextBox 4"/>
+          <p:cNvSpPr txBox="1"/>
+          <p:nvPr/>
+        </p:nvSpPr>
+        <p:spPr>
+          <a:xfrm>
+            <a:off x="502920" y="1417320"/>
+            <a:ext cx="8046720" cy="5120640"/>
+          </a:xfrm>
+          <a:prstGeom prst="rect">
+            <a:avLst/>
+          </a:prstGeom>
+          <a:noFill/>
+        </p:spPr>
+        <p:txBody>
+          <a:bodyPr wrap="square">
+            <a:spAutoFit/>
+          </a:bodyPr>
+          <a:lstStyle/>
+          <a:p>
+            <a:pPr>
+              <a:spcAft>
+                <a:spcPts val="600"/>
+              </a:spcAft>
+              <a:defRPr sz="1600">
+                <a:solidFill>
+                  <a:srgbClr val="0F172A"/>
+                </a:solidFill>
+              </a:defRPr>
+            </a:pPr>
+            <a:r>
               <a:t>git clone https://github.com/mgunjal11/pegasus-qa-agents-lab</a:t>
             </a:r>
           </a:p>
           <a:p>
             <a:pPr>
               <a:spcAft>
-                <a:spcPts val="800"/>
-              </a:spcAft>
-              <a:defRPr sz="1700">
+                <a:spcPts val="600"/>
+              </a:spcAft>
+              <a:defRPr sz="1600">
                 <a:solidFill>
                   <a:srgbClr val="0F172A"/>
                 </a:solidFill>
               </a:defRPr>
             </a:pPr>
             <a:r>
-              <a:t>Enable Atlassian MCP + gh CLI; pip install -r requirements.txt</a:t>
-            </a:r>
-          </a:p>
-          <a:p>
-            <a:pPr>
-              <a:spcAft>
-                <a:spcPts val="800"/>
-              </a:spcAft>
-              <a:defRPr sz="1700">
+              <a:t>cd pegasus-qa-agents-lab &amp;&amp; cursor .</a:t>
+            </a:r>
+          </a:p>
+          <a:p>
+            <a:pPr>
+              <a:spcAft>
+                <a:spcPts val="600"/>
+              </a:spcAft>
+              <a:defRPr sz="1600">
                 <a:solidFill>
                   <a:srgbClr val="0F172A"/>
                 </a:solidFill>
               </a:defRPr>
             </a:pPr>
             <a:r>
+              <a:t>pip install -r requirements.txt &amp;&amp; pip install python-pptx</a:t>
+            </a:r>
+          </a:p>
+          <a:p>
+            <a:pPr>
+              <a:spcAft>
+                <a:spcPts val="600"/>
+              </a:spcAft>
+              <a:defRPr sz="1600">
+                <a:solidFill>
+                  <a:srgbClr val="0F172A"/>
+                </a:solidFill>
+              </a:defRPr>
+            </a:pPr>
+            <a:r>
               <a:t>python scripts/install_coverage_validator_permissions.py</a:t>
             </a:r>
           </a:p>
           <a:p>
             <a:pPr>
               <a:spcAft>
-                <a:spcPts val="800"/>
-              </a:spcAft>
-              <a:defRPr sz="1700">
+                <a:spcPts val="600"/>
+              </a:spcAft>
+              <a:defRPr sz="1600">
                 <a:solidFill>
                   <a:srgbClr val="0F172A"/>
                 </a:solidFill>
               </a:defRPr>
             </a:pPr>
             <a:r>
-              <a:t>In Cursor:  /msc-code-coverage-validator MSC-204417</a:t>
-            </a:r>
-          </a:p>
-          <a:p>
-            <a:pPr>
-              <a:spcAft>
-                <a:spcPts val="800"/>
-              </a:spcAft>
-              <a:defRPr sz="1700">
+              <a:t>cp .env.example .env   # optional, for test plan download</a:t>
+            </a:r>
+          </a:p>
+          <a:p>
+            <a:pPr>
+              <a:spcAft>
+                <a:spcPts val="600"/>
+              </a:spcAft>
+              <a:defRPr sz="1600">
                 <a:solidFill>
                   <a:srgbClr val="0F172A"/>
                 </a:solidFill>
               </a:defRPr>
             </a:pPr>
-          </a:p>
-          <a:p>
-            <a:pPr>
-              <a:spcAft>
-                <a:spcPts val="800"/>
-              </a:spcAft>
-              <a:defRPr sz="1700">
+            <a:r>
+              <a:t>cp …/validator.defaults.example.json .coverage-validator.defaults.json</a:t>
+            </a:r>
+          </a:p>
+          <a:p>
+            <a:pPr>
+              <a:spcAft>
+                <a:spcPts val="600"/>
+              </a:spcAft>
+              <a:defRPr sz="1600">
                 <a:solidFill>
                   <a:srgbClr val="0F172A"/>
                 </a:solidFill>
               </a:defRPr>
             </a:pPr>
             <a:r>
-              <a:t>Sample: MSC-204417 — 100% dev code · 83% dev tests · 2 QA items · Pass with gaps</a:t>
+              <a:t>In Cursor:  /msc-code-coverage-validator MSC-205625</a:t>
+            </a:r>
+          </a:p>
+          <a:p>
+            <a:pPr>
+              <a:spcAft>
+                <a:spcPts val="600"/>
+              </a:spcAft>
+              <a:defRPr sz="1600">
+                <a:solidFill>
+                  <a:srgbClr val="0F172A"/>
+                </a:solidFill>
+              </a:defRPr>
+            </a:pPr>
+            <a:r>
+              <a:t>Generate this deck:  python scripts/generate_coverage_validator_ppt.py</a:t>
             </a:r>
           </a:p>
         </p:txBody>
@@ -4010,7 +5245,7 @@
             <a:avLst/>
           </a:prstGeom>
           <a:solidFill>
-            <a:srgbClr val="1E40AF"/>
+            <a:srgbClr val="C2410C"/>
           </a:solidFill>
           <a:ln>
             <a:noFill/>
@@ -4061,14 +5296,14 @@
           <a:lstStyle/>
           <a:p>
             <a:pPr>
-              <a:defRPr sz="2600" b="1">
+              <a:defRPr sz="2400" b="1">
                 <a:solidFill>
                   <a:srgbClr val="FFFFFF"/>
                 </a:solidFill>
               </a:defRPr>
             </a:pPr>
             <a:r>
-              <a:t>What does this agent do?</a:t>
+              <a:t>Why we need it</a:t>
             </a:r>
           </a:p>
         </p:txBody>
@@ -4081,8 +5316,8 @@
         </p:nvSpPr>
         <p:spPr>
           <a:xfrm>
-            <a:off x="502920" y="1234440"/>
-            <a:ext cx="8046720" cy="5120640"/>
+            <a:off x="502920" y="1051560"/>
+            <a:ext cx="8046720" cy="365760"/>
           </a:xfrm>
           <a:prstGeom prst="rect">
             <a:avLst/>
@@ -4090,6 +5325,41 @@
           <a:noFill/>
         </p:spPr>
         <p:txBody>
+          <a:bodyPr wrap="none">
+            <a:spAutoFit/>
+          </a:bodyPr>
+          <a:lstStyle/>
+          <a:p>
+            <a:pPr>
+              <a:defRPr sz="1300" i="1">
+                <a:solidFill>
+                  <a:srgbClr val="64748B"/>
+                </a:solidFill>
+              </a:defRPr>
+            </a:pPr>
+            <a:r>
+              <a:t>The problem this solves</a:t>
+            </a:r>
+          </a:p>
+        </p:txBody>
+      </p:sp>
+      <p:sp>
+        <p:nvSpPr>
+          <p:cNvPr id="5" name="TextBox 4"/>
+          <p:cNvSpPr txBox="1"/>
+          <p:nvPr/>
+        </p:nvSpPr>
+        <p:spPr>
+          <a:xfrm>
+            <a:off x="502920" y="1417320"/>
+            <a:ext cx="8046720" cy="5120640"/>
+          </a:xfrm>
+          <a:prstGeom prst="rect">
+            <a:avLst/>
+          </a:prstGeom>
+          <a:noFill/>
+        </p:spPr>
+        <p:txBody>
           <a:bodyPr wrap="square">
             <a:spAutoFit/>
           </a:bodyPr>
@@ -4097,76 +5367,76 @@
           <a:p>
             <a:pPr>
               <a:spcAft>
-                <a:spcPts val="800"/>
-              </a:spcAft>
-              <a:defRPr sz="1700">
+                <a:spcPts val="600"/>
+              </a:spcAft>
+              <a:defRPr sz="1600">
                 <a:solidFill>
                   <a:srgbClr val="0F172A"/>
                 </a:solidFill>
               </a:defRPr>
             </a:pPr>
             <a:r>
-              <a:t>Validates MSC Jira user stories against linked GitHub PR(s) or branch code</a:t>
-            </a:r>
-          </a:p>
-          <a:p>
-            <a:pPr>
-              <a:spcAft>
-                <a:spcPts val="800"/>
-              </a:spcAft>
-              <a:defRPr sz="1700">
+              <a:t>Stories ship with acceptance criteria in Jira, code in GitHub, and test plans in QMetry — no single view of readiness</a:t>
+            </a:r>
+          </a:p>
+          <a:p>
+            <a:pPr>
+              <a:spcAft>
+                <a:spcPts val="600"/>
+              </a:spcAft>
+              <a:defRPr sz="1600">
                 <a:solidFill>
                   <a:srgbClr val="0F172A"/>
                 </a:solidFill>
               </a:defRPr>
             </a:pPr>
             <a:r>
-              <a:t>Reads acceptance criteria (AC) from Jira and maps each to production code and tests</a:t>
-            </a:r>
-          </a:p>
-          <a:p>
-            <a:pPr>
-              <a:spcAft>
-                <a:spcPts val="800"/>
-              </a:spcAft>
-              <a:defRPr sz="1700">
+              <a:t>QA and dev often duplicate effort or miss handoffs (unit tests done, Monitor E2E never scheduled)</a:t>
+            </a:r>
+          </a:p>
+          <a:p>
+            <a:pPr>
+              <a:spcAft>
+                <a:spcPts val="600"/>
+              </a:spcAft>
+              <a:defRPr sz="1600">
                 <a:solidFill>
                   <a:srgbClr val="0F172A"/>
                 </a:solidFill>
               </a:defRPr>
             </a:pPr>
             <a:r>
-              <a:t>Separates what Development proves (unit/integration tests) from what QA must still verify</a:t>
-            </a:r>
-          </a:p>
-          <a:p>
-            <a:pPr>
-              <a:spcAft>
-                <a:spcPts val="800"/>
-              </a:spcAft>
-              <a:defRPr sz="1700">
+              <a:t>Release reviews rely on tribal knowledge: “Is the PR linked?” “Does the test plan cover the bug?”</a:t>
+            </a:r>
+          </a:p>
+          <a:p>
+            <a:pPr>
+              <a:spcAft>
+                <a:spcPts val="600"/>
+              </a:spcAft>
+              <a:defRPr sz="1600">
                 <a:solidFill>
                   <a:srgbClr val="0F172A"/>
                 </a:solidFill>
               </a:defRPr>
             </a:pPr>
             <a:r>
-              <a:t>Produces a timestamped HTML report for engineering and QA leadership</a:t>
-            </a:r>
-          </a:p>
-          <a:p>
-            <a:pPr>
-              <a:spcAft>
-                <a:spcPts val="800"/>
-              </a:spcAft>
-              <a:defRPr sz="1700">
+              <a:t>Manual traceability across Jira + PR diff + Excel test plans is slow and inconsistent before sign-off</a:t>
+            </a:r>
+          </a:p>
+          <a:p>
+            <a:pPr>
+              <a:spcAft>
+                <a:spcPts val="600"/>
+              </a:spcAft>
+              <a:defRPr sz="1600">
                 <a:solidFill>
                   <a:srgbClr val="0F172A"/>
                 </a:solidFill>
               </a:defRPr>
             </a:pPr>
             <a:r>
-              <a:t>Run in Cursor:  /msc-code-coverage-validator MSC-204417</a:t>
+              <a:t>Need: one automated, evidence-based report leadership can open in a browser before release</a:t>
             </a:r>
           </a:p>
         </p:txBody>
@@ -4212,7 +5482,7 @@
             <a:avLst/>
           </a:prstGeom>
           <a:solidFill>
-            <a:srgbClr val="2563EB"/>
+            <a:srgbClr val="1E40AF"/>
           </a:solidFill>
           <a:ln>
             <a:noFill/>
@@ -4263,14 +5533,14 @@
           <a:lstStyle/>
           <a:p>
             <a:pPr>
-              <a:defRPr sz="2600" b="1">
+              <a:defRPr sz="2400" b="1">
                 <a:solidFill>
                   <a:srgbClr val="FFFFFF"/>
                 </a:solidFill>
               </a:defRPr>
             </a:pPr>
             <a:r>
-              <a:t>Why leadership cares</a:t>
+              <a:t>Primary uses</a:t>
             </a:r>
           </a:p>
         </p:txBody>
@@ -4305,7 +5575,7 @@
               </a:defRPr>
             </a:pPr>
             <a:r>
-              <a:t>Release confidence in one view</a:t>
+              <a:t>Who runs it and when</a:t>
             </a:r>
           </a:p>
         </p:txBody>
@@ -4334,76 +5604,106 @@
           <a:p>
             <a:pPr>
               <a:spcAft>
-                <a:spcPts val="800"/>
-              </a:spcAft>
-              <a:defRPr sz="1700">
+                <a:spcPts val="600"/>
+              </a:spcAft>
+              <a:defRPr sz="1600">
                 <a:solidFill>
                   <a:srgbClr val="0F172A"/>
                 </a:solidFill>
               </a:defRPr>
             </a:pPr>
             <a:r>
-              <a:t>Traceability — every AC tied to code evidence before sign-off</a:t>
-            </a:r>
-          </a:p>
-          <a:p>
-            <a:pPr>
-              <a:spcAft>
-                <a:spcPts val="800"/>
-              </a:spcAft>
-              <a:defRPr sz="1700">
+              <a:t>QA leads — pre-release readiness check on MSC stories (In QA / Ready for Release)</a:t>
+            </a:r>
+          </a:p>
+          <a:p>
+            <a:pPr>
+              <a:spcAft>
+                <a:spcPts val="600"/>
+              </a:spcAft>
+              <a:defRPr sz="1600">
                 <a:solidFill>
                   <a:srgbClr val="0F172A"/>
                 </a:solidFill>
               </a:defRPr>
             </a:pPr>
             <a:r>
-              <a:t>Clear dev vs QA ownership — avoids duplicate testing or missed handoffs</a:t>
-            </a:r>
-          </a:p>
-          <a:p>
-            <a:pPr>
-              <a:spcAft>
-                <a:spcPts val="800"/>
-              </a:spcAft>
-              <a:defRPr sz="1700">
+              <a:t>Developers — confirm unit/integration tests cover dev-owned acceptance criteria before merge</a:t>
+            </a:r>
+          </a:p>
+          <a:p>
+            <a:pPr>
+              <a:spcAft>
+                <a:spcPts val="600"/>
+              </a:spcAft>
+              <a:defRPr sz="1600">
                 <a:solidFill>
                   <a:srgbClr val="0F172A"/>
                 </a:solidFill>
               </a:defRPr>
             </a:pPr>
             <a:r>
-              <a:t>Quantified metrics — dev code %, dev test %, QA scope, CI coverage, open gaps</a:t>
-            </a:r>
-          </a:p>
-          <a:p>
-            <a:pPr>
-              <a:spcAft>
-                <a:spcPts val="800"/>
-              </a:spcAft>
-              <a:defRPr sz="1700">
+              <a:t>Release managers — snapshot of dev code %, dev test %, QA remaining, and open gaps</a:t>
+            </a:r>
+          </a:p>
+          <a:p>
+            <a:pPr>
+              <a:spcAft>
+                <a:spcPts val="600"/>
+              </a:spcAft>
+              <a:defRPr sz="1600">
                 <a:solidFill>
                   <a:srgbClr val="0F172A"/>
                 </a:solidFill>
               </a:defRPr>
             </a:pPr>
             <a:r>
-              <a:t>Actionable output — gaps, assumptions, and recommended next steps</a:t>
-            </a:r>
-          </a:p>
-          <a:p>
-            <a:pPr>
-              <a:spcAft>
-                <a:spcPts val="800"/>
-              </a:spcAft>
-              <a:defRPr sz="1700">
+              <a:t>Test designers — cross-check attached QMetry / Domino plan vs Jira acceptance criteria</a:t>
+            </a:r>
+          </a:p>
+          <a:p>
+            <a:pPr>
+              <a:spcAft>
+                <a:spcPts val="600"/>
+              </a:spcAft>
+              <a:defRPr sz="1600">
                 <a:solidFill>
                   <a:srgbClr val="0F172A"/>
                 </a:solidFill>
               </a:defRPr>
             </a:pPr>
             <a:r>
-              <a:t>Audit-friendly — downloadable HTML with requirement-level evidence</a:t>
+              <a:t>How to invoke in Cursor:</a:t>
+            </a:r>
+          </a:p>
+          <a:p>
+            <a:pPr lvl="1">
+              <a:spcAft>
+                <a:spcPts val="600"/>
+              </a:spcAft>
+              <a:defRPr sz="1400">
+                <a:solidFill>
+                  <a:srgbClr val="334155"/>
+                </a:solidFill>
+              </a:defRPr>
+            </a:pPr>
+            <a:r>
+              <a:t>  /msc-code-coverage-validator MSC-205625</a:t>
+            </a:r>
+          </a:p>
+          <a:p>
+            <a:pPr lvl="1">
+              <a:spcAft>
+                <a:spcPts val="600"/>
+              </a:spcAft>
+              <a:defRPr sz="1400">
+                <a:solidFill>
+                  <a:srgbClr val="334155"/>
+                </a:solidFill>
+              </a:defRPr>
+            </a:pPr>
+            <a:r>
+              <a:t>  Reuse cache:  /msc-code-coverage-validator MSC-205625 --from-cache --auto</a:t>
             </a:r>
           </a:p>
         </p:txBody>
@@ -4449,7 +5749,7 @@
             <a:avLst/>
           </a:prstGeom>
           <a:solidFill>
-            <a:srgbClr val="334155"/>
+            <a:srgbClr val="2563EB"/>
           </a:solidFill>
           <a:ln>
             <a:noFill/>
@@ -4500,14 +5800,14 @@
           <a:lstStyle/>
           <a:p>
             <a:pPr>
-              <a:defRPr sz="2600" b="1">
+              <a:defRPr sz="2400" b="1">
                 <a:solidFill>
                   <a:srgbClr val="FFFFFF"/>
                 </a:solidFill>
               </a:defRPr>
             </a:pPr>
             <a:r>
-              <a:t>How it works</a:t>
+              <a:t>What the agent delivers</a:t>
             </a:r>
           </a:p>
         </p:txBody>
@@ -4520,8 +5820,8 @@
         </p:nvSpPr>
         <p:spPr>
           <a:xfrm>
-            <a:off x="502920" y="1051560"/>
-            <a:ext cx="8046720" cy="365760"/>
+            <a:off x="502920" y="1234440"/>
+            <a:ext cx="8046720" cy="5120640"/>
           </a:xfrm>
           <a:prstGeom prst="rect">
             <a:avLst/>
@@ -4529,41 +5829,6 @@
           <a:noFill/>
         </p:spPr>
         <p:txBody>
-          <a:bodyPr wrap="none">
-            <a:spAutoFit/>
-          </a:bodyPr>
-          <a:lstStyle/>
-          <a:p>
-            <a:pPr>
-              <a:defRPr sz="1300" i="1">
-                <a:solidFill>
-                  <a:srgbClr val="64748B"/>
-                </a:solidFill>
-              </a:defRPr>
-            </a:pPr>
-            <a:r>
-              <a:t>8-step automated workflow</a:t>
-            </a:r>
-          </a:p>
-        </p:txBody>
-      </p:sp>
-      <p:sp>
-        <p:nvSpPr>
-          <p:cNvPr id="5" name="TextBox 4"/>
-          <p:cNvSpPr txBox="1"/>
-          <p:nvPr/>
-        </p:nvSpPr>
-        <p:spPr>
-          <a:xfrm>
-            <a:off x="502920" y="1417320"/>
-            <a:ext cx="8046720" cy="5120640"/>
-          </a:xfrm>
-          <a:prstGeom prst="rect">
-            <a:avLst/>
-          </a:prstGeom>
-          <a:noFill/>
-        </p:spPr>
-        <p:txBody>
           <a:bodyPr wrap="square">
             <a:spAutoFit/>
           </a:bodyPr>
@@ -4571,91 +5836,76 @@
           <a:p>
             <a:pPr>
               <a:spcAft>
-                <a:spcPts val="800"/>
-              </a:spcAft>
-              <a:defRPr sz="1700">
+                <a:spcPts val="600"/>
+              </a:spcAft>
+              <a:defRPr sz="1600">
                 <a:solidFill>
                   <a:srgbClr val="0F172A"/>
                 </a:solidFill>
               </a:defRPr>
             </a:pPr>
             <a:r>
-              <a:t>1. Fetch Jira story + remote PR links (Atlassian MCP)</a:t>
-            </a:r>
-          </a:p>
-          <a:p>
-            <a:pPr>
-              <a:spcAft>
-                <a:spcPts val="800"/>
-              </a:spcAft>
-              <a:defRPr sz="1700">
+              <a:t>Reads Jira story, linked PR(s) or branch compare, and attached QMetry test plan</a:t>
+            </a:r>
+          </a:p>
+          <a:p>
+            <a:pPr>
+              <a:spcAft>
+                <a:spcPts val="600"/>
+              </a:spcAft>
+              <a:defRPr sz="1600">
                 <a:solidFill>
                   <a:srgbClr val="0F172A"/>
                 </a:solidFill>
               </a:defRPr>
             </a:pPr>
             <a:r>
-              <a:t>2. Resolve GitHub PR or branch compare (gh CLI / cache)</a:t>
-            </a:r>
-          </a:p>
-          <a:p>
-            <a:pPr>
-              <a:spcAft>
-                <a:spcPts val="800"/>
-              </a:spcAft>
-              <a:defRPr sz="1700">
+              <a:t>Maps each acceptance criterion → production code, dev tests, test plan cases, QA scope</a:t>
+            </a:r>
+          </a:p>
+          <a:p>
+            <a:pPr>
+              <a:spcAft>
+                <a:spcPts val="600"/>
+              </a:spcAft>
+              <a:defRPr sz="1600">
                 <a:solidFill>
                   <a:srgbClr val="0F172A"/>
                 </a:solidFill>
               </a:defRPr>
             </a:pPr>
             <a:r>
-              <a:t>3. Extract requirements R1, R2, … from acceptance criteria</a:t>
-            </a:r>
-          </a:p>
-          <a:p>
-            <a:pPr>
-              <a:spcAft>
-                <a:spcPts val="800"/>
-              </a:spcAft>
-              <a:defRPr sz="1700">
+              <a:t>Separates Development proof (unit/integration) from QA handoff (E2E, manual, regression)</a:t>
+            </a:r>
+          </a:p>
+          <a:p>
+            <a:pPr>
+              <a:spcAft>
+                <a:spcPts val="600"/>
+              </a:spcAft>
+              <a:defRPr sz="1600">
                 <a:solidFill>
                   <a:srgbClr val="0F172A"/>
                 </a:solidFill>
               </a:defRPr>
             </a:pPr>
             <a:r>
-              <a:t>4. Map each requirement → code status, dev tests, QA scope</a:t>
-            </a:r>
-          </a:p>
-          <a:p>
-            <a:pPr>
-              <a:spcAft>
-                <a:spcPts val="800"/>
-              </a:spcAft>
-              <a:defRPr sz="1700">
+              <a:t>Outputs timestamped HTML:  reports/{KEY}-{date}-{time}-{TZ}.html</a:t>
+            </a:r>
+          </a:p>
+          <a:p>
+            <a:pPr>
+              <a:spcAft>
+                <a:spcPts val="600"/>
+              </a:spcAft>
+              <a:defRPr sz="1600">
                 <a:solidFill>
                   <a:srgbClr val="0F172A"/>
                 </a:solidFill>
               </a:defRPr>
             </a:pPr>
             <a:r>
-              <a:t>5. Compute coverage percentages and overall verdict</a:t>
-            </a:r>
-          </a:p>
-          <a:p>
-            <a:pPr>
-              <a:spcAft>
-                <a:spcPts val="800"/>
-              </a:spcAft>
-              <a:defRPr sz="1700">
-                <a:solidFill>
-                  <a:srgbClr val="0F172A"/>
-                </a:solidFill>
-              </a:defRPr>
-            </a:pPr>
-            <a:r>
-              <a:t>6. Write HTML report (laptop local timezone filename)</a:t>
+              <a:t>Verdict: Pass · Pass with gaps · Fail — with numbered recommended actions</a:t>
             </a:r>
           </a:p>
         </p:txBody>
@@ -4701,7 +5951,7 @@
             <a:avLst/>
           </a:prstGeom>
           <a:solidFill>
-            <a:srgbClr val="1E40AF"/>
+            <a:srgbClr val="334155"/>
           </a:solidFill>
           <a:ln>
             <a:noFill/>
@@ -4752,14 +6002,14 @@
           <a:lstStyle/>
           <a:p>
             <a:pPr>
-              <a:defRPr sz="2600" b="1">
+              <a:defRPr sz="2400" b="1">
                 <a:solidFill>
                   <a:srgbClr val="FFFFFF"/>
                 </a:solidFill>
               </a:defRPr>
             </a:pPr>
             <a:r>
-              <a:t>Report structure</a:t>
+              <a:t>Why leadership cares</a:t>
             </a:r>
           </a:p>
         </p:txBody>
@@ -4794,7 +6044,7 @@
               </a:defRPr>
             </a:pPr>
             <a:r>
-              <a:t>Header + 7 numbered sections</a:t>
+              <a:t>Release confidence in one view</a:t>
             </a:r>
           </a:p>
         </p:txBody>
@@ -4823,106 +6073,76 @@
           <a:p>
             <a:pPr>
               <a:spcAft>
-                <a:spcPts val="800"/>
-              </a:spcAft>
-              <a:defRPr sz="1700">
+                <a:spcPts val="600"/>
+              </a:spcAft>
+              <a:defRPr sz="1600">
                 <a:solidFill>
                   <a:srgbClr val="0F172A"/>
                 </a:solidFill>
               </a:defRPr>
             </a:pPr>
             <a:r>
-              <a:t>Header — Story title, Jira link, status, verdict (Pass / Pass with gaps / Fail)</a:t>
-            </a:r>
-          </a:p>
-          <a:p>
-            <a:pPr>
-              <a:spcAft>
-                <a:spcPts val="800"/>
-              </a:spcAft>
-              <a:defRPr sz="1700">
+              <a:t>Traceability — every acceptance criterion tied to code and test evidence</a:t>
+            </a:r>
+          </a:p>
+          <a:p>
+            <a:pPr>
+              <a:spcAft>
+                <a:spcPts val="600"/>
+              </a:spcAft>
+              <a:defRPr sz="1600">
                 <a:solidFill>
                   <a:srgbClr val="0F172A"/>
                 </a:solidFill>
               </a:defRPr>
             </a:pPr>
             <a:r>
-              <a:t>§1 Coverage summary — 7 metric cards in 3 logical groups</a:t>
-            </a:r>
-          </a:p>
-          <a:p>
-            <a:pPr>
-              <a:spcAft>
-                <a:spcPts val="800"/>
-              </a:spcAft>
-              <a:defRPr sz="1700">
+              <a:t>Quantified metrics — 8 summary cards (dev, QA, test plan, CI)</a:t>
+            </a:r>
+          </a:p>
+          <a:p>
+            <a:pPr>
+              <a:spcAft>
+                <a:spcPts val="600"/>
+              </a:spcAft>
+              <a:defRPr sz="1600">
                 <a:solidFill>
                   <a:srgbClr val="0F172A"/>
                 </a:solidFill>
               </a:defRPr>
             </a:pPr>
             <a:r>
-              <a:t>§2 Linked PR(s) — Where code lives; CI status</a:t>
-            </a:r>
-          </a:p>
-          <a:p>
-            <a:pPr>
-              <a:spcAft>
-                <a:spcPts val="800"/>
-              </a:spcAft>
-              <a:defRPr sz="1700">
+              <a:t>Clear ownership — no ambiguity on what QA must still run in SIT/UAT</a:t>
+            </a:r>
+          </a:p>
+          <a:p>
+            <a:pPr>
+              <a:spcAft>
+                <a:spcPts val="600"/>
+              </a:spcAft>
+              <a:defRPr sz="1600">
                 <a:solidFill>
                   <a:srgbClr val="0F172A"/>
                 </a:solidFill>
               </a:defRPr>
             </a:pPr>
             <a:r>
-              <a:t>§3 Dev vs QA test ownership — Who tests what</a:t>
-            </a:r>
-          </a:p>
-          <a:p>
-            <a:pPr>
-              <a:spcAft>
-                <a:spcPts val="800"/>
-              </a:spcAft>
-              <a:defRPr sz="1700">
+              <a:t>Test plan alignment — Domino / QMetry scenarios vs implementation (when attached)</a:t>
+            </a:r>
+          </a:p>
+          <a:p>
+            <a:pPr>
+              <a:spcAft>
+                <a:spcPts val="600"/>
+              </a:spcAft>
+              <a:defRPr sz="1600">
                 <a:solidFill>
                   <a:srgbClr val="0F172A"/>
                 </a:solidFill>
               </a:defRPr>
             </a:pPr>
             <a:r>
-              <a:t>§4 Requirements traceability — AC-by-AC audit table</a:t>
-            </a:r>
-          </a:p>
-          <a:p>
-            <a:pPr>
-              <a:spcAft>
-                <a:spcPts val="800"/>
-              </a:spcAft>
-              <a:defRPr sz="1700">
-                <a:solidFill>
-                  <a:srgbClr val="0F172A"/>
-                </a:solidFill>
-              </a:defRPr>
-            </a:pPr>
-            <a:r>
-              <a:t>§5 Implementation review — Strengths and gaps</a:t>
-            </a:r>
-          </a:p>
-          <a:p>
-            <a:pPr>
-              <a:spcAft>
-                <a:spcPts val="800"/>
-              </a:spcAft>
-              <a:defRPr sz="1700">
-                <a:solidFill>
-                  <a:srgbClr val="0F172A"/>
-                </a:solidFill>
-              </a:defRPr>
-            </a:pPr>
-            <a:r>
-              <a:t>§6 Assumptions · §7 Recommended actions</a:t>
+              <a:t>Audit-friendly — downloadable HTML; shareable with engineering and product</a:t>
             </a:r>
           </a:p>
         </p:txBody>
@@ -4998,65 +6218,13 @@
       </p:sp>
       <p:sp>
         <p:nvSpPr>
-          <p:cNvPr id="3" name="Oval 2"/>
-          <p:cNvSpPr/>
-          <p:nvPr/>
-        </p:nvSpPr>
-        <p:spPr>
-          <a:xfrm>
-            <a:off x="320040" y="201168"/>
-            <a:ext cx="502920" cy="502920"/>
-          </a:xfrm>
-          <a:prstGeom prst="ellipse">
-            <a:avLst/>
-          </a:prstGeom>
-          <a:solidFill>
-            <a:srgbClr val="FFFFFF"/>
-          </a:solidFill>
-          <a:ln>
-            <a:noFill/>
-          </a:ln>
-        </p:spPr>
-        <p:style>
-          <a:lnRef idx="1">
-            <a:schemeClr val="accent1"/>
-          </a:lnRef>
-          <a:fillRef idx="3">
-            <a:schemeClr val="accent1"/>
-          </a:fillRef>
-          <a:effectRef idx="2">
-            <a:schemeClr val="accent1"/>
-          </a:effectRef>
-          <a:fontRef idx="minor">
-            <a:schemeClr val="lt1"/>
-          </a:fontRef>
-        </p:style>
-        <p:txBody>
-          <a:bodyPr rtlCol="0" anchor="ctr"/>
-          <a:lstStyle/>
-          <a:p>
-            <a:pPr algn="ctr">
-              <a:defRPr sz="1400" b="1">
-                <a:solidFill>
-                  <a:srgbClr val="FFFFFF"/>
-                </a:solidFill>
-              </a:defRPr>
-            </a:pPr>
-            <a:r>
-              <a:t>1</a:t>
-            </a:r>
-          </a:p>
-        </p:txBody>
-      </p:sp>
-      <p:sp>
-        <p:nvSpPr>
-          <p:cNvPr id="4" name="TextBox 3"/>
+          <p:cNvPr id="3" name="TextBox 2"/>
           <p:cNvSpPr txBox="1"/>
           <p:nvPr/>
         </p:nvSpPr>
         <p:spPr>
           <a:xfrm>
-            <a:off x="960120" y="164592"/>
+            <a:off x="411480" y="164592"/>
             <a:ext cx="7772400" cy="640080"/>
           </a:xfrm>
           <a:prstGeom prst="rect">
@@ -5071,21 +6239,21 @@
           <a:lstStyle/>
           <a:p>
             <a:pPr>
-              <a:defRPr sz="2600" b="1">
+              <a:defRPr sz="2400" b="1">
                 <a:solidFill>
                   <a:srgbClr val="FFFFFF"/>
                 </a:solidFill>
               </a:defRPr>
             </a:pPr>
             <a:r>
-              <a:t>§1 Coverage summary</a:t>
-            </a:r>
-          </a:p>
-        </p:txBody>
-      </p:sp>
-      <p:sp>
-        <p:nvSpPr>
-          <p:cNvPr id="5" name="TextBox 4"/>
+              <a:t>How it works</a:t>
+            </a:r>
+          </a:p>
+        </p:txBody>
+      </p:sp>
+      <p:sp>
+        <p:nvSpPr>
+          <p:cNvPr id="4" name="TextBox 3"/>
           <p:cNvSpPr txBox="1"/>
           <p:nvPr/>
         </p:nvSpPr>
@@ -5113,14 +6281,14 @@
               </a:defRPr>
             </a:pPr>
             <a:r>
-              <a:t>7 cards · 3 groups · restrained color coding</a:t>
-            </a:r>
-          </a:p>
-        </p:txBody>
-      </p:sp>
-      <p:sp>
-        <p:nvSpPr>
-          <p:cNvPr id="6" name="TextBox 5"/>
+              <a:t>Automated workflow (≈2–5 min)</a:t>
+            </a:r>
+          </a:p>
+        </p:txBody>
+      </p:sp>
+      <p:sp>
+        <p:nvSpPr>
+          <p:cNvPr id="5" name="TextBox 4"/>
           <p:cNvSpPr txBox="1"/>
           <p:nvPr/>
         </p:nvSpPr>
@@ -5142,136 +6310,91 @@
           <a:p>
             <a:pPr>
               <a:spcAft>
-                <a:spcPts val="800"/>
-              </a:spcAft>
-              <a:defRPr sz="1700">
+                <a:spcPts val="600"/>
+              </a:spcAft>
+              <a:defRPr sz="1600">
                 <a:solidFill>
                   <a:srgbClr val="0F172A"/>
                 </a:solidFill>
               </a:defRPr>
             </a:pPr>
             <a:r>
-              <a:t>Implementation &amp; tests</a:t>
-            </a:r>
-          </a:p>
-          <a:p>
-            <a:pPr lvl="1">
-              <a:spcAft>
-                <a:spcPts val="800"/>
-              </a:spcAft>
-              <a:defRPr sz="1500">
-                <a:solidFill>
-                  <a:srgbClr val="334155"/>
-                </a:solidFill>
-              </a:defRPr>
-            </a:pPr>
-            <a:r>
-              <a:t>  • Dev code coverage — % of Jira AC with matching production code (green ≥85%)</a:t>
-            </a:r>
-          </a:p>
-          <a:p>
-            <a:pPr lvl="1">
-              <a:spcAft>
-                <a:spcPts val="800"/>
-              </a:spcAft>
-              <a:defRPr sz="1500">
-                <a:solidFill>
-                  <a:srgbClr val="334155"/>
-                </a:solidFill>
-              </a:defRPr>
-            </a:pPr>
-            <a:r>
-              <a:t>  • Dev unit / integration test coverage — dev-owned AC covered by PR tests</a:t>
-            </a:r>
-          </a:p>
-          <a:p>
-            <a:pPr lvl="1">
-              <a:spcAft>
-                <a:spcPts val="800"/>
-              </a:spcAft>
-              <a:defRPr sz="1500">
-                <a:solidFill>
-                  <a:srgbClr val="334155"/>
-                </a:solidFill>
-              </a:defRPr>
-            </a:pPr>
-            <a:r>
-              <a:t>  • Requirements mapped — e.g. 3/3 AC (R1–R3) extracted from Jira</a:t>
-            </a:r>
-          </a:p>
-          <a:p>
-            <a:pPr>
-              <a:spcAft>
-                <a:spcPts val="800"/>
-              </a:spcAft>
-              <a:defRPr sz="1700">
+              <a:t>1. Fetch Jira issue + remote PR links (Atlassian MCP, one batch)</a:t>
+            </a:r>
+          </a:p>
+          <a:p>
+            <a:pPr>
+              <a:spcAft>
+                <a:spcPts val="600"/>
+              </a:spcAft>
+              <a:defRPr sz="1600">
                 <a:solidFill>
                   <a:srgbClr val="0F172A"/>
                 </a:solidFill>
               </a:defRPr>
             </a:pPr>
             <a:r>
-              <a:t>QA &amp; release risk</a:t>
-            </a:r>
-          </a:p>
-          <a:p>
-            <a:pPr lvl="1">
-              <a:spcAft>
-                <a:spcPts val="800"/>
-              </a:spcAft>
-              <a:defRPr sz="1500">
-                <a:solidFill>
-                  <a:srgbClr val="334155"/>
-                </a:solidFill>
-              </a:defRPr>
-            </a:pPr>
-            <a:r>
-              <a:t>  • QA scope remaining — items needing E2E, manual, or regression</a:t>
-            </a:r>
-          </a:p>
-          <a:p>
-            <a:pPr lvl="1">
-              <a:spcAft>
-                <a:spcPts val="800"/>
-              </a:spcAft>
-              <a:defRPr sz="1500">
-                <a:solidFill>
-                  <a:srgbClr val="334155"/>
-                </a:solidFill>
-              </a:defRPr>
-            </a:pPr>
-            <a:r>
-              <a:t>  • Open gaps — High / Medium counts from implementation review</a:t>
-            </a:r>
-          </a:p>
-          <a:p>
-            <a:pPr>
-              <a:spcAft>
-                <a:spcPts val="800"/>
-              </a:spcAft>
-              <a:defRPr sz="1700">
+              <a:t>2. Download/parse QMetry test plan from Jira attachment or local testplans/</a:t>
+            </a:r>
+          </a:p>
+          <a:p>
+            <a:pPr>
+              <a:spcAft>
+                <a:spcPts val="600"/>
+              </a:spcAft>
+              <a:defRPr sz="1600">
                 <a:solidFill>
                   <a:srgbClr val="0F172A"/>
                 </a:solidFill>
               </a:defRPr>
             </a:pPr>
             <a:r>
-              <a:t>CI pipeline coverage</a:t>
-            </a:r>
-          </a:p>
-          <a:p>
-            <a:pPr lvl="1">
-              <a:spcAft>
-                <a:spcPts val="800"/>
-              </a:spcAft>
-              <a:defRPr sz="1500">
-                <a:solidFill>
-                  <a:srgbClr val="334155"/>
-                </a:solidFill>
-              </a:defRPr>
-            </a:pPr>
-            <a:r>
-              <a:t>  • CI line coverage · CI branch coverage (NA when no PR)</a:t>
+              <a:t>3. Prefetch GitHub PR diff, checks, CI coverage (single script; cached for reuse)</a:t>
+            </a:r>
+          </a:p>
+          <a:p>
+            <a:pPr>
+              <a:spcAft>
+                <a:spcPts val="600"/>
+              </a:spcAft>
+              <a:defRPr sz="1600">
+                <a:solidFill>
+                  <a:srgbClr val="0F172A"/>
+                </a:solidFill>
+              </a:defRPr>
+            </a:pPr>
+            <a:r>
+              <a:t>4. Extract requirements R1, R2, … from acceptance criteria + LADR comments</a:t>
+            </a:r>
+          </a:p>
+          <a:p>
+            <a:pPr>
+              <a:spcAft>
+                <a:spcPts val="600"/>
+              </a:spcAft>
+              <a:defRPr sz="1600">
+                <a:solidFill>
+                  <a:srgbClr val="0F172A"/>
+                </a:solidFill>
+              </a:defRPr>
+            </a:pPr>
+            <a:r>
+              <a:t>5. Score code, dev tests, test plan mapping, QA scope per requirement</a:t>
+            </a:r>
+          </a:p>
+          <a:p>
+            <a:pPr>
+              <a:spcAft>
+                <a:spcPts val="600"/>
+              </a:spcAft>
+              <a:defRPr sz="1600">
+                <a:solidFill>
+                  <a:srgbClr val="0F172A"/>
+                </a:solidFill>
+              </a:defRPr>
+            </a:pPr>
+            <a:r>
+              <a:t>6. Write HTML report + save manifest under reports/.cache/</a:t>
             </a:r>
           </a:p>
         </p:txBody>
@@ -5317,7 +6440,7 @@
             <a:avLst/>
           </a:prstGeom>
           <a:solidFill>
-            <a:srgbClr val="3730A3"/>
+            <a:srgbClr val="1E40AF"/>
           </a:solidFill>
           <a:ln>
             <a:noFill/>
@@ -5347,65 +6470,13 @@
       </p:sp>
       <p:sp>
         <p:nvSpPr>
-          <p:cNvPr id="3" name="Oval 2"/>
-          <p:cNvSpPr/>
-          <p:nvPr/>
-        </p:nvSpPr>
-        <p:spPr>
-          <a:xfrm>
-            <a:off x="320040" y="201168"/>
-            <a:ext cx="502920" cy="502920"/>
-          </a:xfrm>
-          <a:prstGeom prst="ellipse">
-            <a:avLst/>
-          </a:prstGeom>
-          <a:solidFill>
-            <a:srgbClr val="FFFFFF"/>
-          </a:solidFill>
-          <a:ln>
-            <a:noFill/>
-          </a:ln>
-        </p:spPr>
-        <p:style>
-          <a:lnRef idx="1">
-            <a:schemeClr val="accent1"/>
-          </a:lnRef>
-          <a:fillRef idx="3">
-            <a:schemeClr val="accent1"/>
-          </a:fillRef>
-          <a:effectRef idx="2">
-            <a:schemeClr val="accent1"/>
-          </a:effectRef>
-          <a:fontRef idx="minor">
-            <a:schemeClr val="lt1"/>
-          </a:fontRef>
-        </p:style>
-        <p:txBody>
-          <a:bodyPr rtlCol="0" anchor="ctr"/>
-          <a:lstStyle/>
-          <a:p>
-            <a:pPr algn="ctr">
-              <a:defRPr sz="1400" b="1">
-                <a:solidFill>
-                  <a:srgbClr val="FFFFFF"/>
-                </a:solidFill>
-              </a:defRPr>
-            </a:pPr>
-            <a:r>
-              <a:t>2</a:t>
-            </a:r>
-          </a:p>
-        </p:txBody>
-      </p:sp>
-      <p:sp>
-        <p:nvSpPr>
-          <p:cNvPr id="4" name="TextBox 3"/>
+          <p:cNvPr id="3" name="TextBox 2"/>
           <p:cNvSpPr txBox="1"/>
           <p:nvPr/>
         </p:nvSpPr>
         <p:spPr>
           <a:xfrm>
-            <a:off x="960120" y="164592"/>
+            <a:off x="411480" y="164592"/>
             <a:ext cx="7772400" cy="640080"/>
           </a:xfrm>
           <a:prstGeom prst="rect">
@@ -5420,21 +6491,21 @@
           <a:lstStyle/>
           <a:p>
             <a:pPr>
-              <a:defRPr sz="2600" b="1">
+              <a:defRPr sz="2400" b="1">
                 <a:solidFill>
                   <a:srgbClr val="FFFFFF"/>
                 </a:solidFill>
               </a:defRPr>
             </a:pPr>
             <a:r>
-              <a:t>§2 Linked PR(s)</a:t>
-            </a:r>
-          </a:p>
-        </p:txBody>
-      </p:sp>
-      <p:sp>
-        <p:nvSpPr>
-          <p:cNvPr id="5" name="TextBox 4"/>
+              <a:t>HTML report — overview</a:t>
+            </a:r>
+          </a:p>
+        </p:txBody>
+      </p:sp>
+      <p:sp>
+        <p:nvSpPr>
+          <p:cNvPr id="4" name="TextBox 3"/>
           <p:cNvSpPr txBox="1"/>
           <p:nvPr/>
         </p:nvSpPr>
@@ -5462,14 +6533,14 @@
               </a:defRPr>
             </a:pPr>
             <a:r>
-              <a:t>Source code traceability</a:t>
-            </a:r>
-          </a:p>
-        </p:txBody>
-      </p:sp>
-      <p:sp>
-        <p:nvSpPr>
-          <p:cNvPr id="6" name="TextBox 5"/>
+              <a:t>8 numbered sections + header</a:t>
+            </a:r>
+          </a:p>
+        </p:txBody>
+      </p:sp>
+      <p:sp>
+        <p:nvSpPr>
+          <p:cNvPr id="5" name="TextBox 4"/>
           <p:cNvSpPr txBox="1"/>
           <p:nvPr/>
         </p:nvSpPr>
@@ -5491,61 +6562,106 @@
           <a:p>
             <a:pPr>
               <a:spcAft>
-                <a:spcPts val="800"/>
-              </a:spcAft>
-              <a:defRPr sz="1700">
+                <a:spcPts val="600"/>
+              </a:spcAft>
+              <a:defRPr sz="1600">
                 <a:solidFill>
                   <a:srgbClr val="0F172A"/>
                 </a:solidFill>
               </a:defRPr>
             </a:pPr>
             <a:r>
-              <a:t>Lists PR(s) linked to the Jira story (remote links, description, or search)</a:t>
-            </a:r>
-          </a:p>
-          <a:p>
-            <a:pPr>
-              <a:spcAft>
-                <a:spcPts val="800"/>
-              </a:spcAft>
-              <a:defRPr sz="1700">
+              <a:t>Header — Story title, Jira link, status, verdict, generation time (local TZ)</a:t>
+            </a:r>
+          </a:p>
+          <a:p>
+            <a:pPr>
+              <a:spcAft>
+                <a:spcPts val="600"/>
+              </a:spcAft>
+              <a:defRPr sz="1600">
                 <a:solidFill>
                   <a:srgbClr val="0F172A"/>
                 </a:solidFill>
               </a:defRPr>
             </a:pPr>
             <a:r>
-              <a:t>Shows author, state (open/merged), and CI outcome per PR</a:t>
-            </a:r>
-          </a:p>
-          <a:p>
-            <a:pPr>
-              <a:spcAft>
-                <a:spcPts val="800"/>
-              </a:spcAft>
-              <a:defRPr sz="1700">
+              <a:t>§1 Coverage summary — 8 metric cards in 3 groups</a:t>
+            </a:r>
+          </a:p>
+          <a:p>
+            <a:pPr>
+              <a:spcAft>
+                <a:spcPts val="600"/>
+              </a:spcAft>
+              <a:defRPr sz="1600">
                 <a:solidFill>
                   <a:srgbClr val="0F172A"/>
                 </a:solidFill>
               </a:defRPr>
             </a:pPr>
             <a:r>
-              <a:t>If no PR: notes branch compare (e.g. develop vs main) and key commits</a:t>
-            </a:r>
-          </a:p>
-          <a:p>
-            <a:pPr>
-              <a:spcAft>
-                <a:spcPts val="800"/>
-              </a:spcAft>
-              <a:defRPr sz="1700">
+              <a:t>§2 Linked PR(s) — GitHub traceability and CI</a:t>
+            </a:r>
+          </a:p>
+          <a:p>
+            <a:pPr>
+              <a:spcAft>
+                <a:spcPts val="600"/>
+              </a:spcAft>
+              <a:defRPr sz="1600">
                 <a:solidFill>
                   <a:srgbClr val="0F172A"/>
                 </a:solidFill>
               </a:defRPr>
             </a:pPr>
             <a:r>
-              <a:t>Answers: “Where is this story implemented and is it reviewable in GitHub?”</a:t>
+              <a:t>§3 Attached test plan validation — QMetry/Domino vs acceptance criteria</a:t>
+            </a:r>
+          </a:p>
+          <a:p>
+            <a:pPr>
+              <a:spcAft>
+                <a:spcPts val="600"/>
+              </a:spcAft>
+              <a:defRPr sz="1600">
+                <a:solidFill>
+                  <a:srgbClr val="0F172A"/>
+                </a:solidFill>
+              </a:defRPr>
+            </a:pPr>
+            <a:r>
+              <a:t>§4 Dev vs QA test ownership — handoff lists</a:t>
+            </a:r>
+          </a:p>
+          <a:p>
+            <a:pPr>
+              <a:spcAft>
+                <a:spcPts val="600"/>
+              </a:spcAft>
+              <a:defRPr sz="1600">
+                <a:solidFill>
+                  <a:srgbClr val="0F172A"/>
+                </a:solidFill>
+              </a:defRPr>
+            </a:pPr>
+            <a:r>
+              <a:t>§5 Requirements traceability — row-per-AC audit matrix</a:t>
+            </a:r>
+          </a:p>
+          <a:p>
+            <a:pPr>
+              <a:spcAft>
+                <a:spcPts val="600"/>
+              </a:spcAft>
+              <a:defRPr sz="1600">
+                <a:solidFill>
+                  <a:srgbClr val="0F172A"/>
+                </a:solidFill>
+              </a:defRPr>
+            </a:pPr>
+            <a:r>
+              <a:t>§6 Implementation review · §7 Assumptions · §8 Recommended actions</a:t>
             </a:r>
           </a:p>
         </p:txBody>
@@ -5591,7 +6707,7 @@
             <a:avLst/>
           </a:prstGeom>
           <a:solidFill>
-            <a:srgbClr val="0E7490"/>
+            <a:srgbClr val="2563EB"/>
           </a:solidFill>
           <a:ln>
             <a:noFill/>
@@ -5666,7 +6782,7 @@
               </a:defRPr>
             </a:pPr>
             <a:r>
-              <a:t>3</a:t>
+              <a:t>1</a:t>
             </a:r>
           </a:p>
         </p:txBody>
@@ -5694,14 +6810,14 @@
           <a:lstStyle/>
           <a:p>
             <a:pPr>
-              <a:defRPr sz="2600" b="1">
+              <a:defRPr sz="2400" b="1">
                 <a:solidFill>
                   <a:srgbClr val="FFFFFF"/>
                 </a:solidFill>
               </a:defRPr>
             </a:pPr>
             <a:r>
-              <a:t>§3 Dev vs QA ownership</a:t>
+              <a:t>§1 Coverage summary explained</a:t>
             </a:r>
           </a:p>
         </p:txBody>
@@ -5736,7 +6852,7 @@
               </a:defRPr>
             </a:pPr>
             <a:r>
-              <a:t>Two-column handoff view</a:t>
+              <a:t>8 cards · 3 groups · color thresholds</a:t>
             </a:r>
           </a:p>
         </p:txBody>
@@ -5765,91 +6881,166 @@
           <a:p>
             <a:pPr>
               <a:spcAft>
-                <a:spcPts val="800"/>
-              </a:spcAft>
-              <a:defRPr sz="1700">
+                <a:spcPts val="600"/>
+              </a:spcAft>
+              <a:defRPr sz="1600">
                 <a:solidFill>
                   <a:srgbClr val="0F172A"/>
                 </a:solidFill>
               </a:defRPr>
             </a:pPr>
             <a:r>
-              <a:t>Covered by dev tests — Requirements proven by unit/integration tests in the PR</a:t>
+              <a:t>Implementation &amp; tests</a:t>
             </a:r>
           </a:p>
           <a:p>
             <a:pPr lvl="1">
               <a:spcAft>
-                <a:spcPts val="800"/>
-              </a:spcAft>
-              <a:defRPr sz="1500">
+                <a:spcPts val="600"/>
+              </a:spcAft>
+              <a:defRPr sz="1400">
                 <a:solidFill>
                   <a:srgbClr val="334155"/>
                 </a:solidFill>
               </a:defRPr>
             </a:pPr>
             <a:r>
-              <a:t>  • Lists requirement ID + test file / test name evidence</a:t>
-            </a:r>
-          </a:p>
-          <a:p>
-            <a:pPr>
-              <a:spcAft>
-                <a:spcPts val="800"/>
-              </a:spcAft>
-              <a:defRPr sz="1700">
+              <a:t>  • Dev code coverage — % of acceptance criteria with matching production code</a:t>
+            </a:r>
+          </a:p>
+          <a:p>
+            <a:pPr lvl="1">
+              <a:spcAft>
+                <a:spcPts val="600"/>
+              </a:spcAft>
+              <a:defRPr sz="1400">
+                <a:solidFill>
+                  <a:srgbClr val="334155"/>
+                </a:solidFill>
+              </a:defRPr>
+            </a:pPr>
+            <a:r>
+              <a:t>  • Dev unit/integration test coverage — dev-owned AC covered by PR tests</a:t>
+            </a:r>
+          </a:p>
+          <a:p>
+            <a:pPr lvl="1">
+              <a:spcAft>
+                <a:spcPts val="600"/>
+              </a:spcAft>
+              <a:defRPr sz="1400">
+                <a:solidFill>
+                  <a:srgbClr val="334155"/>
+                </a:solidFill>
+              </a:defRPr>
+            </a:pPr>
+            <a:r>
+              <a:t>  • Requirements mapped — e.g. 4/4 acceptance criteria (R1–R4)</a:t>
+            </a:r>
+          </a:p>
+          <a:p>
+            <a:pPr>
+              <a:spcAft>
+                <a:spcPts val="600"/>
+              </a:spcAft>
+              <a:defRPr sz="1600">
                 <a:solidFill>
                   <a:srgbClr val="0F172A"/>
                 </a:solidFill>
               </a:defRPr>
             </a:pPr>
             <a:r>
-              <a:t>QA handoff — What automated tests do NOT fully cover</a:t>
+              <a:t>QA &amp; release risk</a:t>
             </a:r>
           </a:p>
           <a:p>
             <a:pPr lvl="1">
               <a:spcAft>
-                <a:spcPts val="800"/>
-              </a:spcAft>
-              <a:defRPr sz="1500">
+                <a:spcPts val="600"/>
+              </a:spcAft>
+              <a:defRPr sz="1400">
                 <a:solidFill>
                   <a:srgbClr val="334155"/>
                 </a:solidFill>
               </a:defRPr>
             </a:pPr>
             <a:r>
-              <a:t>  • E2E — end-to-end flows (Monitor, staging, UI)</a:t>
+              <a:t>  • Test plan acceptance criteria coverage — % AC with ≥1 mapped test case</a:t>
             </a:r>
           </a:p>
           <a:p>
             <a:pPr lvl="1">
               <a:spcAft>
-                <a:spcPts val="800"/>
-              </a:spcAft>
-              <a:defRPr sz="1500">
+                <a:spcPts val="600"/>
+              </a:spcAft>
+              <a:defRPr sz="1400">
                 <a:solidFill>
                   <a:srgbClr val="334155"/>
                 </a:solidFill>
               </a:defRPr>
             </a:pPr>
             <a:r>
-              <a:t>  • Manual / Spot-check — exploratory or payload verification</a:t>
+              <a:t>  • QA scope remaining — E2E, manual, regression still required</a:t>
             </a:r>
           </a:p>
           <a:p>
             <a:pPr lvl="1">
               <a:spcAft>
-                <a:spcPts val="800"/>
-              </a:spcAft>
-              <a:defRPr sz="1500">
+                <a:spcPts val="600"/>
+              </a:spcAft>
+              <a:defRPr sz="1400">
                 <a:solidFill>
                   <a:srgbClr val="334155"/>
                 </a:solidFill>
               </a:defRPr>
             </a:pPr>
             <a:r>
-              <a:t>  • Regression — confirm related fixes in QA build</a:t>
+              <a:t>  • Open gaps — High / Medium from implementation review</a:t>
+            </a:r>
+          </a:p>
+          <a:p>
+            <a:pPr>
+              <a:spcAft>
+                <a:spcPts val="600"/>
+              </a:spcAft>
+              <a:defRPr sz="1600">
+                <a:solidFill>
+                  <a:srgbClr val="0F172A"/>
+                </a:solidFill>
+              </a:defRPr>
+            </a:pPr>
+            <a:r>
+              <a:t>CI pipeline</a:t>
+            </a:r>
+          </a:p>
+          <a:p>
+            <a:pPr lvl="1">
+              <a:spcAft>
+                <a:spcPts val="600"/>
+              </a:spcAft>
+              <a:defRPr sz="1400">
+                <a:solidFill>
+                  <a:srgbClr val="334155"/>
+                </a:solidFill>
+              </a:defRPr>
+            </a:pPr>
+            <a:r>
+              <a:t>  • CI line coverage · CI branch coverage (NA if no PR / checks unavailable)</a:t>
+            </a:r>
+          </a:p>
+          <a:p>
+            <a:pPr>
+              <a:spcAft>
+                <a:spcPts val="600"/>
+              </a:spcAft>
+              <a:defRPr sz="1600">
+                <a:solidFill>
+                  <a:srgbClr val="0F172A"/>
+                </a:solidFill>
+              </a:defRPr>
+            </a:pPr>
+            <a:r>
+              <a:t>Colors: Green ≥85% · Amber 70–84.9% · Red &lt;70% · Gray NA</a:t>
             </a:r>
           </a:p>
         </p:txBody>
@@ -5895,7 +7086,7 @@
             <a:avLst/>
           </a:prstGeom>
           <a:solidFill>
-            <a:srgbClr val="5B21B6"/>
+            <a:srgbClr val="3730A3"/>
           </a:solidFill>
           <a:ln>
             <a:noFill/>
@@ -5970,7 +7161,7 @@
               </a:defRPr>
             </a:pPr>
             <a:r>
-              <a:t>4</a:t>
+              <a:t>2–3</a:t>
             </a:r>
           </a:p>
         </p:txBody>
@@ -5998,14 +7189,14 @@
           <a:lstStyle/>
           <a:p>
             <a:pPr>
-              <a:defRPr sz="2600" b="1">
+              <a:defRPr sz="2400" b="1">
                 <a:solidFill>
                   <a:srgbClr val="FFFFFF"/>
                 </a:solidFill>
               </a:defRPr>
             </a:pPr>
             <a:r>
-              <a:t>§4 Requirements traceability</a:t>
+              <a:t>§2–§3 PR &amp; test plan</a:t>
             </a:r>
           </a:p>
         </p:txBody>
@@ -6018,8 +7209,8 @@
         </p:nvSpPr>
         <p:spPr>
           <a:xfrm>
-            <a:off x="502920" y="1051560"/>
-            <a:ext cx="8046720" cy="365760"/>
+            <a:off x="502920" y="1234440"/>
+            <a:ext cx="8046720" cy="5120640"/>
           </a:xfrm>
           <a:prstGeom prst="rect">
             <a:avLst/>
@@ -6027,41 +7218,6 @@
           <a:noFill/>
         </p:spPr>
         <p:txBody>
-          <a:bodyPr wrap="none">
-            <a:spAutoFit/>
-          </a:bodyPr>
-          <a:lstStyle/>
-          <a:p>
-            <a:pPr>
-              <a:defRPr sz="1300" i="1">
-                <a:solidFill>
-                  <a:srgbClr val="64748B"/>
-                </a:solidFill>
-              </a:defRPr>
-            </a:pPr>
-            <a:r>
-              <a:t>Core audit matrix</a:t>
-            </a:r>
-          </a:p>
-        </p:txBody>
-      </p:sp>
-      <p:sp>
-        <p:nvSpPr>
-          <p:cNvPr id="6" name="TextBox 5"/>
-          <p:cNvSpPr txBox="1"/>
-          <p:nvPr/>
-        </p:nvSpPr>
-        <p:spPr>
-          <a:xfrm>
-            <a:off x="502920" y="1417320"/>
-            <a:ext cx="8046720" cy="5120640"/>
-          </a:xfrm>
-          <a:prstGeom prst="rect">
-            <a:avLst/>
-          </a:prstGeom>
-          <a:noFill/>
-        </p:spPr>
-        <p:txBody>
           <a:bodyPr wrap="square">
             <a:spAutoFit/>
           </a:bodyPr>
@@ -6069,91 +7225,121 @@
           <a:p>
             <a:pPr>
               <a:spcAft>
-                <a:spcPts val="800"/>
-              </a:spcAft>
-              <a:defRPr sz="1700">
+                <a:spcPts val="600"/>
+              </a:spcAft>
+              <a:defRPr sz="1600">
                 <a:solidFill>
                   <a:srgbClr val="0F172A"/>
                 </a:solidFill>
               </a:defRPr>
             </a:pPr>
             <a:r>
-              <a:t>One row per acceptance criterion (R1, R2, …)</a:t>
-            </a:r>
-          </a:p>
-          <a:p>
-            <a:pPr>
-              <a:spcAft>
-                <a:spcPts val="800"/>
-              </a:spcAft>
-              <a:defRPr sz="1700">
+              <a:t>§2 Linked PR(s)</a:t>
+            </a:r>
+          </a:p>
+          <a:p>
+            <a:pPr lvl="1">
+              <a:spcAft>
+                <a:spcPts val="600"/>
+              </a:spcAft>
+              <a:defRPr sz="1400">
+                <a:solidFill>
+                  <a:srgbClr val="334155"/>
+                </a:solidFill>
+              </a:defRPr>
+            </a:pPr>
+            <a:r>
+              <a:t>  • PR URL, author, merged/open, CI status</a:t>
+            </a:r>
+          </a:p>
+          <a:p>
+            <a:pPr lvl="1">
+              <a:spcAft>
+                <a:spcPts val="600"/>
+              </a:spcAft>
+              <a:defRPr sz="1400">
+                <a:solidFill>
+                  <a:srgbClr val="334155"/>
+                </a:solidFill>
+              </a:defRPr>
+            </a:pPr>
+            <a:r>
+              <a:t>  • If no PR: develop vs main compare + key commits (e.g. pegasus-ess)</a:t>
+            </a:r>
+          </a:p>
+          <a:p>
+            <a:pPr>
+              <a:spcAft>
+                <a:spcPts val="600"/>
+              </a:spcAft>
+              <a:defRPr sz="1600">
                 <a:solidFill>
                   <a:srgbClr val="0F172A"/>
                 </a:solidFill>
               </a:defRPr>
             </a:pPr>
             <a:r>
-              <a:t>Code — Implemented · Partial · Missing</a:t>
-            </a:r>
-          </a:p>
-          <a:p>
-            <a:pPr>
-              <a:spcAft>
-                <a:spcPts val="800"/>
-              </a:spcAft>
-              <a:defRPr sz="1700">
+              <a:t>§3 Attached test plan validation</a:t>
+            </a:r>
+          </a:p>
+          <a:p>
+            <a:pPr lvl="1">
+              <a:spcAft>
+                <a:spcPts val="600"/>
+              </a:spcAft>
+              <a:defRPr sz="1400">
+                <a:solidFill>
+                  <a:srgbClr val="334155"/>
+                </a:solidFill>
+              </a:defRPr>
+            </a:pPr>
+            <a:r>
+              <a:t>  • Parses Jira attachment (Domino Test Plan.xlsx) or SharePoint reference</a:t>
+            </a:r>
+          </a:p>
+          <a:p>
+            <a:pPr lvl="1">
+              <a:spcAft>
+                <a:spcPts val="600"/>
+              </a:spcAft>
+              <a:defRPr sz="1400">
+                <a:solidFill>
+                  <a:srgbClr val="334155"/>
+                </a:solidFill>
+              </a:defRPr>
+            </a:pPr>
+            <a:r>
+              <a:t>  • Section · Summary scenarios, Given/When/Then, Mascot evidence links</a:t>
+            </a:r>
+          </a:p>
+          <a:p>
+            <a:pPr lvl="1">
+              <a:spcAft>
+                <a:spcPts val="600"/>
+              </a:spcAft>
+              <a:defRPr sz="1400">
+                <a:solidFill>
+                  <a:srgbClr val="334155"/>
+                </a:solidFill>
+              </a:defRPr>
+            </a:pPr>
+            <a:r>
+              <a:t>  • Maps test cases to R1…Rn; lists gaps (uncovered AC, weak Then steps)</a:t>
+            </a:r>
+          </a:p>
+          <a:p>
+            <a:pPr>
+              <a:spcAft>
+                <a:spcPts val="600"/>
+              </a:spcAft>
+              <a:defRPr sz="1600">
                 <a:solidFill>
                   <a:srgbClr val="0F172A"/>
                 </a:solidFill>
               </a:defRPr>
             </a:pPr>
             <a:r>
-              <a:t>Dev tests — Covered · Partial · Missing + Unit/Integration tier</a:t>
-            </a:r>
-          </a:p>
-          <a:p>
-            <a:pPr>
-              <a:spcAft>
-                <a:spcPts val="800"/>
-              </a:spcAft>
-              <a:defRPr sz="1700">
-                <a:solidFill>
-                  <a:srgbClr val="0F172A"/>
-                </a:solidFill>
-              </a:defRPr>
-            </a:pPr>
-            <a:r>
-              <a:t>Owner — Dev · Shared · QA</a:t>
-            </a:r>
-          </a:p>
-          <a:p>
-            <a:pPr>
-              <a:spcAft>
-                <a:spcPts val="800"/>
-              </a:spcAft>
-              <a:defRPr sz="1700">
-                <a:solidFill>
-                  <a:srgbClr val="0F172A"/>
-                </a:solidFill>
-              </a:defRPr>
-            </a:pPr>
-            <a:r>
-              <a:t>QA scope — None · E2E · Manual · Spot-check · Regression</a:t>
-            </a:r>
-          </a:p>
-          <a:p>
-            <a:pPr>
-              <a:spcAft>
-                <a:spcPts val="800"/>
-              </a:spcAft>
-              <a:defRPr sz="1700">
-                <a:solidFill>
-                  <a:srgbClr val="0F172A"/>
-                </a:solidFill>
-              </a:defRPr>
-            </a:pPr>
-            <a:r>
-              <a:t>Evidence — File paths, functions, and test names from the PR diff</a:t>
+              <a:t>Example: MSC-205625 — 5 scenarios, 75% test plan AC coverage, R4 SIT gap</a:t>
             </a:r>
           </a:p>
         </p:txBody>

</xml_diff>